<commit_message>
OMC karhutla: slide 3 kesimpulan efektivitas dan riset literatur
Co-Authored-By: Claude Opus 5.5 <noreply@anthropic.com>
</commit_message>
<xml_diff>
--- a/data/laporan-bnpb/omc/OMC_Karhutla_16-27Okt2026.pptx
+++ b/data/laporan-bnpb/omc/OMC_Karhutla_16-27Okt2026.pptx
@@ -7,9 +7,10 @@
   <p:sldIdLst>
     <p:sldId id="256" r:id="rId2"/>
     <p:sldId id="257" r:id="rId3"/>
+    <p:sldId id="258" r:id="rId4"/>
   </p:sldIdLst>
   <p:notesMasterIdLst>
-    <p:notesMasterId r:id="rId4"/>
+    <p:notesMasterId r:id="rId5"/>
   </p:notesMasterIdLst>
   <p:sldSz cx="12192000" cy="6858000"/>
   <p:notesSz cx="6858000" cy="12192000"/>
@@ -615,6 +616,94 @@
             <a:fld id="{F7021451-1387-4CA6-816F-3879F97B5CBC}" type="slidenum">
               <a:rPr lang="en-US"/>
               <a:t>2</a:t>
+            </a:fld>
+            <a:endParaRPr lang="en-US"/>
+          </a:p>
+        </p:txBody>
+      </p:sp>
+    </p:spTree>
+    <p:extLst>
+      <p:ext uri="{BB962C8B-B14F-4D97-AF65-F5344CB8AC3E}">
+        <p14:creationId xmlns:p14="http://schemas.microsoft.com/office/powerpoint/2010/main" val="1024086991"/>
+      </p:ext>
+    </p:extLst>
+  </p:cSld>
+  <p:clrMapOvr>
+    <a:masterClrMapping/>
+  </p:clrMapOvr>
+</p:notes>
+</file>
+
+<file path=ppt/notesSlides/notesSlide3.xml><?xml version="1.0" encoding="utf-8"?>
+<p:notes xmlns:a="http://schemas.openxmlformats.org/drawingml/2006/main" xmlns:r="http://schemas.openxmlformats.org/officeDocument/2006/relationships" xmlns:p="http://schemas.openxmlformats.org/presentationml/2006/main">
+  <p:cSld>
+    <p:spTree>
+      <p:nvGrpSpPr>
+        <p:cNvPr id="1" name=""/>
+        <p:cNvGrpSpPr/>
+        <p:nvPr/>
+      </p:nvGrpSpPr>
+      <p:grpSpPr>
+        <a:xfrm>
+          <a:off x="0" y="0"/>
+          <a:ext cx="0" cy="0"/>
+          <a:chOff x="0" y="0"/>
+          <a:chExt cx="0" cy="0"/>
+        </a:xfrm>
+      </p:grpSpPr>
+      <p:sp>
+        <p:nvSpPr>
+          <p:cNvPr id="2" name="Slide Image Placeholder 1"/>
+          <p:cNvSpPr>
+            <a:spLocks noGrp="1" noRot="1" noChangeAspect="1"/>
+          </p:cNvSpPr>
+          <p:nvPr>
+            <p:ph type="sldImg"/>
+          </p:nvPr>
+        </p:nvSpPr>
+        <p:spPr/>
+      </p:sp>
+      <p:sp>
+        <p:nvSpPr>
+          <p:cNvPr id="3" name="Notes Placeholder 2"/>
+          <p:cNvSpPr>
+            <a:spLocks noGrp="1"/>
+          </p:cNvSpPr>
+          <p:nvPr>
+            <p:ph type="body" idx="1"/>
+          </p:nvPr>
+        </p:nvSpPr>
+        <p:spPr/>
+        <p:txBody>
+          <a:bodyPr/>
+          <a:lstStyle/>
+          <a:p>
+            <a:r>
+              <a:rPr lang="en-US" dirty="0"/>
+              <a:t/>
+            </a:r>
+            <a:endParaRPr lang="en-US" dirty="0"/>
+          </a:p>
+        </p:txBody>
+      </p:sp>
+      <p:sp>
+        <p:nvSpPr>
+          <p:cNvPr id="4" name="Slide Number Placeholder 3"/>
+          <p:cNvSpPr>
+            <a:spLocks noGrp="1"/>
+          </p:cNvSpPr>
+          <p:nvPr>
+            <p:ph type="sldNum" sz="quarter" idx="10"/>
+          </p:nvPr>
+        </p:nvSpPr>
+        <p:spPr/>
+        <p:txBody>
+          <a:bodyPr/>
+          <a:lstStyle/>
+          <a:p>
+            <a:fld id="{F7021451-1387-4CA6-816F-3879F97B5CBC}" type="slidenum">
+              <a:rPr lang="en-US"/>
+              <a:t>3</a:t>
             </a:fld>
             <a:endParaRPr lang="en-US"/>
           </a:p>
@@ -2882,7 +2971,7 @@
         <p:spPr>
           <a:xfrm>
             <a:off x="676656" y="2883916"/>
-            <a:ext cx="608607" cy="182880"/>
+            <a:ext cx="542260" cy="182880"/>
           </a:xfrm>
           <a:prstGeom prst="rect">
             <a:avLst/>
@@ -2920,8 +3009,8 @@
         </p:nvSpPr>
         <p:spPr>
           <a:xfrm>
-            <a:off x="1340127" y="2883916"/>
-            <a:ext cx="873995" cy="182880"/>
+            <a:off x="1273780" y="2883916"/>
+            <a:ext cx="807648" cy="182880"/>
           </a:xfrm>
           <a:prstGeom prst="rect">
             <a:avLst/>
@@ -2959,8 +3048,8 @@
         </p:nvSpPr>
         <p:spPr>
           <a:xfrm>
-            <a:off x="2268986" y="2883916"/>
-            <a:ext cx="1006690" cy="182880"/>
+            <a:off x="2136292" y="2883916"/>
+            <a:ext cx="940342" cy="182880"/>
           </a:xfrm>
           <a:prstGeom prst="rect">
             <a:avLst/>
@@ -2998,8 +3087,8 @@
         </p:nvSpPr>
         <p:spPr>
           <a:xfrm>
-            <a:off x="3330540" y="2883916"/>
-            <a:ext cx="873995" cy="182880"/>
+            <a:off x="3131498" y="2883916"/>
+            <a:ext cx="807648" cy="182880"/>
           </a:xfrm>
           <a:prstGeom prst="rect">
             <a:avLst/>
@@ -3037,8 +3126,8 @@
         </p:nvSpPr>
         <p:spPr>
           <a:xfrm>
-            <a:off x="4259399" y="2883916"/>
-            <a:ext cx="1006690" cy="182880"/>
+            <a:off x="3994011" y="2883916"/>
+            <a:ext cx="940342" cy="182880"/>
           </a:xfrm>
           <a:prstGeom prst="rect">
             <a:avLst/>
@@ -3076,8 +3165,8 @@
         </p:nvSpPr>
         <p:spPr>
           <a:xfrm>
-            <a:off x="5320953" y="2883916"/>
-            <a:ext cx="873995" cy="182880"/>
+            <a:off x="4989217" y="2883916"/>
+            <a:ext cx="1272078" cy="182880"/>
           </a:xfrm>
           <a:prstGeom prst="rect">
             <a:avLst/>
@@ -3115,8 +3204,8 @@
         </p:nvSpPr>
         <p:spPr>
           <a:xfrm>
-            <a:off x="6249812" y="2883916"/>
-            <a:ext cx="1006690" cy="182880"/>
+            <a:off x="6316159" y="2883916"/>
+            <a:ext cx="940342" cy="182880"/>
           </a:xfrm>
           <a:prstGeom prst="rect">
             <a:avLst/>
@@ -3178,7 +3267,7 @@
         <p:spPr>
           <a:xfrm>
             <a:off x="676656" y="3112516"/>
-            <a:ext cx="608607" cy="196596"/>
+            <a:ext cx="542260" cy="196596"/>
           </a:xfrm>
           <a:prstGeom prst="rect">
             <a:avLst/>
@@ -3216,8 +3305,8 @@
         </p:nvSpPr>
         <p:spPr>
           <a:xfrm>
-            <a:off x="1340127" y="3112516"/>
-            <a:ext cx="873995" cy="196596"/>
+            <a:off x="1273780" y="3112516"/>
+            <a:ext cx="807648" cy="196596"/>
           </a:xfrm>
           <a:prstGeom prst="rect">
             <a:avLst/>
@@ -3255,8 +3344,8 @@
         </p:nvSpPr>
         <p:spPr>
           <a:xfrm>
-            <a:off x="2268986" y="3112516"/>
-            <a:ext cx="1006690" cy="196596"/>
+            <a:off x="2136292" y="3112516"/>
+            <a:ext cx="940342" cy="196596"/>
           </a:xfrm>
           <a:prstGeom prst="rect">
             <a:avLst/>
@@ -3294,8 +3383,8 @@
         </p:nvSpPr>
         <p:spPr>
           <a:xfrm>
-            <a:off x="3330540" y="3112516"/>
-            <a:ext cx="873995" cy="196596"/>
+            <a:off x="3131498" y="3112516"/>
+            <a:ext cx="807648" cy="196596"/>
           </a:xfrm>
           <a:prstGeom prst="rect">
             <a:avLst/>
@@ -3333,8 +3422,8 @@
         </p:nvSpPr>
         <p:spPr>
           <a:xfrm>
-            <a:off x="4259399" y="3112516"/>
-            <a:ext cx="1006690" cy="196596"/>
+            <a:off x="3994011" y="3112516"/>
+            <a:ext cx="940342" cy="196596"/>
           </a:xfrm>
           <a:prstGeom prst="rect">
             <a:avLst/>
@@ -3372,8 +3461,8 @@
         </p:nvSpPr>
         <p:spPr>
           <a:xfrm>
-            <a:off x="5320953" y="3112516"/>
-            <a:ext cx="873995" cy="196596"/>
+            <a:off x="4989217" y="3112516"/>
+            <a:ext cx="1272078" cy="196596"/>
           </a:xfrm>
           <a:prstGeom prst="rect">
             <a:avLst/>
@@ -3411,8 +3500,8 @@
         </p:nvSpPr>
         <p:spPr>
           <a:xfrm>
-            <a:off x="6249812" y="3112516"/>
-            <a:ext cx="1006690" cy="196596"/>
+            <a:off x="6316159" y="3112516"/>
+            <a:ext cx="940342" cy="196596"/>
           </a:xfrm>
           <a:prstGeom prst="rect">
             <a:avLst/>
@@ -3474,7 +3563,7 @@
         <p:spPr>
           <a:xfrm>
             <a:off x="676656" y="3309112"/>
-            <a:ext cx="608607" cy="196596"/>
+            <a:ext cx="542260" cy="196596"/>
           </a:xfrm>
           <a:prstGeom prst="rect">
             <a:avLst/>
@@ -3512,8 +3601,8 @@
         </p:nvSpPr>
         <p:spPr>
           <a:xfrm>
-            <a:off x="1340127" y="3309112"/>
-            <a:ext cx="873995" cy="196596"/>
+            <a:off x="1273780" y="3309112"/>
+            <a:ext cx="807648" cy="196596"/>
           </a:xfrm>
           <a:prstGeom prst="rect">
             <a:avLst/>
@@ -3551,8 +3640,8 @@
         </p:nvSpPr>
         <p:spPr>
           <a:xfrm>
-            <a:off x="2268986" y="3309112"/>
-            <a:ext cx="1006690" cy="196596"/>
+            <a:off x="2136292" y="3309112"/>
+            <a:ext cx="940342" cy="196596"/>
           </a:xfrm>
           <a:prstGeom prst="rect">
             <a:avLst/>
@@ -3590,8 +3679,8 @@
         </p:nvSpPr>
         <p:spPr>
           <a:xfrm>
-            <a:off x="3330540" y="3309112"/>
-            <a:ext cx="873995" cy="196596"/>
+            <a:off x="3131498" y="3309112"/>
+            <a:ext cx="807648" cy="196596"/>
           </a:xfrm>
           <a:prstGeom prst="rect">
             <a:avLst/>
@@ -3629,8 +3718,8 @@
         </p:nvSpPr>
         <p:spPr>
           <a:xfrm>
-            <a:off x="4259399" y="3309112"/>
-            <a:ext cx="1006690" cy="196596"/>
+            <a:off x="3994011" y="3309112"/>
+            <a:ext cx="940342" cy="196596"/>
           </a:xfrm>
           <a:prstGeom prst="rect">
             <a:avLst/>
@@ -3668,8 +3757,8 @@
         </p:nvSpPr>
         <p:spPr>
           <a:xfrm>
-            <a:off x="5320953" y="3309112"/>
-            <a:ext cx="873995" cy="196596"/>
+            <a:off x="4989217" y="3309112"/>
+            <a:ext cx="1272078" cy="196596"/>
           </a:xfrm>
           <a:prstGeom prst="rect">
             <a:avLst/>
@@ -3707,8 +3796,8 @@
         </p:nvSpPr>
         <p:spPr>
           <a:xfrm>
-            <a:off x="6249812" y="3309112"/>
-            <a:ext cx="1006690" cy="196596"/>
+            <a:off x="6316159" y="3309112"/>
+            <a:ext cx="940342" cy="196596"/>
           </a:xfrm>
           <a:prstGeom prst="rect">
             <a:avLst/>
@@ -3770,7 +3859,7 @@
         <p:spPr>
           <a:xfrm>
             <a:off x="676656" y="3505708"/>
-            <a:ext cx="608607" cy="196596"/>
+            <a:ext cx="542260" cy="196596"/>
           </a:xfrm>
           <a:prstGeom prst="rect">
             <a:avLst/>
@@ -3808,8 +3897,8 @@
         </p:nvSpPr>
         <p:spPr>
           <a:xfrm>
-            <a:off x="1340127" y="3505708"/>
-            <a:ext cx="873995" cy="196596"/>
+            <a:off x="1273780" y="3505708"/>
+            <a:ext cx="807648" cy="196596"/>
           </a:xfrm>
           <a:prstGeom prst="rect">
             <a:avLst/>
@@ -3847,8 +3936,8 @@
         </p:nvSpPr>
         <p:spPr>
           <a:xfrm>
-            <a:off x="2268986" y="3505708"/>
-            <a:ext cx="1006690" cy="196596"/>
+            <a:off x="2136292" y="3505708"/>
+            <a:ext cx="940342" cy="196596"/>
           </a:xfrm>
           <a:prstGeom prst="rect">
             <a:avLst/>
@@ -3886,8 +3975,8 @@
         </p:nvSpPr>
         <p:spPr>
           <a:xfrm>
-            <a:off x="3330540" y="3505708"/>
-            <a:ext cx="873995" cy="196596"/>
+            <a:off x="3131498" y="3505708"/>
+            <a:ext cx="807648" cy="196596"/>
           </a:xfrm>
           <a:prstGeom prst="rect">
             <a:avLst/>
@@ -3925,8 +4014,8 @@
         </p:nvSpPr>
         <p:spPr>
           <a:xfrm>
-            <a:off x="4259399" y="3505708"/>
-            <a:ext cx="1006690" cy="196596"/>
+            <a:off x="3994011" y="3505708"/>
+            <a:ext cx="940342" cy="196596"/>
           </a:xfrm>
           <a:prstGeom prst="rect">
             <a:avLst/>
@@ -3964,8 +4053,8 @@
         </p:nvSpPr>
         <p:spPr>
           <a:xfrm>
-            <a:off x="5320953" y="3505708"/>
-            <a:ext cx="873995" cy="196596"/>
+            <a:off x="4989217" y="3505708"/>
+            <a:ext cx="1272078" cy="196596"/>
           </a:xfrm>
           <a:prstGeom prst="rect">
             <a:avLst/>
@@ -4003,8 +4092,8 @@
         </p:nvSpPr>
         <p:spPr>
           <a:xfrm>
-            <a:off x="6249812" y="3505708"/>
-            <a:ext cx="1006690" cy="196596"/>
+            <a:off x="6316159" y="3505708"/>
+            <a:ext cx="940342" cy="196596"/>
           </a:xfrm>
           <a:prstGeom prst="rect">
             <a:avLst/>
@@ -4066,7 +4155,7 @@
         <p:spPr>
           <a:xfrm>
             <a:off x="676656" y="3702304"/>
-            <a:ext cx="608607" cy="196596"/>
+            <a:ext cx="542260" cy="196596"/>
           </a:xfrm>
           <a:prstGeom prst="rect">
             <a:avLst/>
@@ -4104,8 +4193,8 @@
         </p:nvSpPr>
         <p:spPr>
           <a:xfrm>
-            <a:off x="1340127" y="3702304"/>
-            <a:ext cx="873995" cy="196596"/>
+            <a:off x="1273780" y="3702304"/>
+            <a:ext cx="807648" cy="196596"/>
           </a:xfrm>
           <a:prstGeom prst="rect">
             <a:avLst/>
@@ -4143,8 +4232,8 @@
         </p:nvSpPr>
         <p:spPr>
           <a:xfrm>
-            <a:off x="2268986" y="3702304"/>
-            <a:ext cx="1006690" cy="196596"/>
+            <a:off x="2136292" y="3702304"/>
+            <a:ext cx="940342" cy="196596"/>
           </a:xfrm>
           <a:prstGeom prst="rect">
             <a:avLst/>
@@ -4182,8 +4271,8 @@
         </p:nvSpPr>
         <p:spPr>
           <a:xfrm>
-            <a:off x="3330540" y="3702304"/>
-            <a:ext cx="873995" cy="196596"/>
+            <a:off x="3131498" y="3702304"/>
+            <a:ext cx="807648" cy="196596"/>
           </a:xfrm>
           <a:prstGeom prst="rect">
             <a:avLst/>
@@ -4221,8 +4310,8 @@
         </p:nvSpPr>
         <p:spPr>
           <a:xfrm>
-            <a:off x="4259399" y="3702304"/>
-            <a:ext cx="1006690" cy="196596"/>
+            <a:off x="3994011" y="3702304"/>
+            <a:ext cx="940342" cy="196596"/>
           </a:xfrm>
           <a:prstGeom prst="rect">
             <a:avLst/>
@@ -4260,8 +4349,8 @@
         </p:nvSpPr>
         <p:spPr>
           <a:xfrm>
-            <a:off x="5320953" y="3702304"/>
-            <a:ext cx="873995" cy="196596"/>
+            <a:off x="4989217" y="3702304"/>
+            <a:ext cx="1272078" cy="196596"/>
           </a:xfrm>
           <a:prstGeom prst="rect">
             <a:avLst/>
@@ -4299,8 +4388,8 @@
         </p:nvSpPr>
         <p:spPr>
           <a:xfrm>
-            <a:off x="6249812" y="3702304"/>
-            <a:ext cx="1006690" cy="196596"/>
+            <a:off x="6316159" y="3702304"/>
+            <a:ext cx="940342" cy="196596"/>
           </a:xfrm>
           <a:prstGeom prst="rect">
             <a:avLst/>
@@ -4362,7 +4451,7 @@
         <p:spPr>
           <a:xfrm>
             <a:off x="676656" y="3898900"/>
-            <a:ext cx="608607" cy="196596"/>
+            <a:ext cx="542260" cy="196596"/>
           </a:xfrm>
           <a:prstGeom prst="rect">
             <a:avLst/>
@@ -4400,8 +4489,8 @@
         </p:nvSpPr>
         <p:spPr>
           <a:xfrm>
-            <a:off x="1340127" y="3898900"/>
-            <a:ext cx="873995" cy="196596"/>
+            <a:off x="1273780" y="3898900"/>
+            <a:ext cx="807648" cy="196596"/>
           </a:xfrm>
           <a:prstGeom prst="rect">
             <a:avLst/>
@@ -4439,8 +4528,8 @@
         </p:nvSpPr>
         <p:spPr>
           <a:xfrm>
-            <a:off x="2268986" y="3898900"/>
-            <a:ext cx="1006690" cy="196596"/>
+            <a:off x="2136292" y="3898900"/>
+            <a:ext cx="940342" cy="196596"/>
           </a:xfrm>
           <a:prstGeom prst="rect">
             <a:avLst/>
@@ -4478,8 +4567,8 @@
         </p:nvSpPr>
         <p:spPr>
           <a:xfrm>
-            <a:off x="3330540" y="3898900"/>
-            <a:ext cx="873995" cy="196596"/>
+            <a:off x="3131498" y="3898900"/>
+            <a:ext cx="807648" cy="196596"/>
           </a:xfrm>
           <a:prstGeom prst="rect">
             <a:avLst/>
@@ -4517,8 +4606,8 @@
         </p:nvSpPr>
         <p:spPr>
           <a:xfrm>
-            <a:off x="4259399" y="3898900"/>
-            <a:ext cx="1006690" cy="196596"/>
+            <a:off x="3994011" y="3898900"/>
+            <a:ext cx="940342" cy="196596"/>
           </a:xfrm>
           <a:prstGeom prst="rect">
             <a:avLst/>
@@ -4556,8 +4645,8 @@
         </p:nvSpPr>
         <p:spPr>
           <a:xfrm>
-            <a:off x="5320953" y="3898900"/>
-            <a:ext cx="873995" cy="196596"/>
+            <a:off x="4989217" y="3898900"/>
+            <a:ext cx="1272078" cy="196596"/>
           </a:xfrm>
           <a:prstGeom prst="rect">
             <a:avLst/>
@@ -4595,8 +4684,8 @@
         </p:nvSpPr>
         <p:spPr>
           <a:xfrm>
-            <a:off x="6249812" y="3898900"/>
-            <a:ext cx="1006690" cy="196596"/>
+            <a:off x="6316159" y="3898900"/>
+            <a:ext cx="940342" cy="196596"/>
           </a:xfrm>
           <a:prstGeom prst="rect">
             <a:avLst/>
@@ -4658,7 +4747,7 @@
         <p:spPr>
           <a:xfrm>
             <a:off x="676656" y="4095496"/>
-            <a:ext cx="608607" cy="196596"/>
+            <a:ext cx="542260" cy="196596"/>
           </a:xfrm>
           <a:prstGeom prst="rect">
             <a:avLst/>
@@ -4696,8 +4785,8 @@
         </p:nvSpPr>
         <p:spPr>
           <a:xfrm>
-            <a:off x="1340127" y="4095496"/>
-            <a:ext cx="873995" cy="196596"/>
+            <a:off x="1273780" y="4095496"/>
+            <a:ext cx="807648" cy="196596"/>
           </a:xfrm>
           <a:prstGeom prst="rect">
             <a:avLst/>
@@ -4735,8 +4824,8 @@
         </p:nvSpPr>
         <p:spPr>
           <a:xfrm>
-            <a:off x="2268986" y="4095496"/>
-            <a:ext cx="1006690" cy="196596"/>
+            <a:off x="2136292" y="4095496"/>
+            <a:ext cx="940342" cy="196596"/>
           </a:xfrm>
           <a:prstGeom prst="rect">
             <a:avLst/>
@@ -4774,8 +4863,8 @@
         </p:nvSpPr>
         <p:spPr>
           <a:xfrm>
-            <a:off x="3330540" y="4095496"/>
-            <a:ext cx="873995" cy="196596"/>
+            <a:off x="3131498" y="4095496"/>
+            <a:ext cx="807648" cy="196596"/>
           </a:xfrm>
           <a:prstGeom prst="rect">
             <a:avLst/>
@@ -4813,8 +4902,8 @@
         </p:nvSpPr>
         <p:spPr>
           <a:xfrm>
-            <a:off x="4259399" y="4095496"/>
-            <a:ext cx="1006690" cy="196596"/>
+            <a:off x="3994011" y="4095496"/>
+            <a:ext cx="940342" cy="196596"/>
           </a:xfrm>
           <a:prstGeom prst="rect">
             <a:avLst/>
@@ -4852,8 +4941,8 @@
         </p:nvSpPr>
         <p:spPr>
           <a:xfrm>
-            <a:off x="5320953" y="4095496"/>
-            <a:ext cx="873995" cy="196596"/>
+            <a:off x="4989217" y="4095496"/>
+            <a:ext cx="1272078" cy="196596"/>
           </a:xfrm>
           <a:prstGeom prst="rect">
             <a:avLst/>
@@ -4891,8 +4980,8 @@
         </p:nvSpPr>
         <p:spPr>
           <a:xfrm>
-            <a:off x="6249812" y="4095496"/>
-            <a:ext cx="1006690" cy="196596"/>
+            <a:off x="6316159" y="4095496"/>
+            <a:ext cx="940342" cy="196596"/>
           </a:xfrm>
           <a:prstGeom prst="rect">
             <a:avLst/>
@@ -4954,7 +5043,7 @@
         <p:spPr>
           <a:xfrm>
             <a:off x="676656" y="4292092"/>
-            <a:ext cx="608607" cy="196596"/>
+            <a:ext cx="542260" cy="196596"/>
           </a:xfrm>
           <a:prstGeom prst="rect">
             <a:avLst/>
@@ -4992,8 +5081,8 @@
         </p:nvSpPr>
         <p:spPr>
           <a:xfrm>
-            <a:off x="1340127" y="4292092"/>
-            <a:ext cx="873995" cy="196596"/>
+            <a:off x="1273780" y="4292092"/>
+            <a:ext cx="807648" cy="196596"/>
           </a:xfrm>
           <a:prstGeom prst="rect">
             <a:avLst/>
@@ -5031,8 +5120,8 @@
         </p:nvSpPr>
         <p:spPr>
           <a:xfrm>
-            <a:off x="2268986" y="4292092"/>
-            <a:ext cx="1006690" cy="196596"/>
+            <a:off x="2136292" y="4292092"/>
+            <a:ext cx="940342" cy="196596"/>
           </a:xfrm>
           <a:prstGeom prst="rect">
             <a:avLst/>
@@ -5070,8 +5159,8 @@
         </p:nvSpPr>
         <p:spPr>
           <a:xfrm>
-            <a:off x="3330540" y="4292092"/>
-            <a:ext cx="873995" cy="196596"/>
+            <a:off x="3131498" y="4292092"/>
+            <a:ext cx="807648" cy="196596"/>
           </a:xfrm>
           <a:prstGeom prst="rect">
             <a:avLst/>
@@ -5109,8 +5198,8 @@
         </p:nvSpPr>
         <p:spPr>
           <a:xfrm>
-            <a:off x="4259399" y="4292092"/>
-            <a:ext cx="1006690" cy="196596"/>
+            <a:off x="3994011" y="4292092"/>
+            <a:ext cx="940342" cy="196596"/>
           </a:xfrm>
           <a:prstGeom prst="rect">
             <a:avLst/>
@@ -5148,8 +5237,8 @@
         </p:nvSpPr>
         <p:spPr>
           <a:xfrm>
-            <a:off x="5320953" y="4292092"/>
-            <a:ext cx="873995" cy="196596"/>
+            <a:off x="4989217" y="4292092"/>
+            <a:ext cx="1272078" cy="196596"/>
           </a:xfrm>
           <a:prstGeom prst="rect">
             <a:avLst/>
@@ -5187,8 +5276,8 @@
         </p:nvSpPr>
         <p:spPr>
           <a:xfrm>
-            <a:off x="6249812" y="4292092"/>
-            <a:ext cx="1006690" cy="196596"/>
+            <a:off x="6316159" y="4292092"/>
+            <a:ext cx="940342" cy="196596"/>
           </a:xfrm>
           <a:prstGeom prst="rect">
             <a:avLst/>
@@ -5250,7 +5339,7 @@
         <p:spPr>
           <a:xfrm>
             <a:off x="676656" y="4488688"/>
-            <a:ext cx="608607" cy="196596"/>
+            <a:ext cx="542260" cy="196596"/>
           </a:xfrm>
           <a:prstGeom prst="rect">
             <a:avLst/>
@@ -5288,8 +5377,8 @@
         </p:nvSpPr>
         <p:spPr>
           <a:xfrm>
-            <a:off x="1340127" y="4488688"/>
-            <a:ext cx="873995" cy="196596"/>
+            <a:off x="1273780" y="4488688"/>
+            <a:ext cx="807648" cy="196596"/>
           </a:xfrm>
           <a:prstGeom prst="rect">
             <a:avLst/>
@@ -5327,8 +5416,8 @@
         </p:nvSpPr>
         <p:spPr>
           <a:xfrm>
-            <a:off x="2268986" y="4488688"/>
-            <a:ext cx="1006690" cy="196596"/>
+            <a:off x="2136292" y="4488688"/>
+            <a:ext cx="940342" cy="196596"/>
           </a:xfrm>
           <a:prstGeom prst="rect">
             <a:avLst/>
@@ -5366,8 +5455,8 @@
         </p:nvSpPr>
         <p:spPr>
           <a:xfrm>
-            <a:off x="3330540" y="4488688"/>
-            <a:ext cx="873995" cy="196596"/>
+            <a:off x="3131498" y="4488688"/>
+            <a:ext cx="807648" cy="196596"/>
           </a:xfrm>
           <a:prstGeom prst="rect">
             <a:avLst/>
@@ -5405,8 +5494,8 @@
         </p:nvSpPr>
         <p:spPr>
           <a:xfrm>
-            <a:off x="4259399" y="4488688"/>
-            <a:ext cx="1006690" cy="196596"/>
+            <a:off x="3994011" y="4488688"/>
+            <a:ext cx="940342" cy="196596"/>
           </a:xfrm>
           <a:prstGeom prst="rect">
             <a:avLst/>
@@ -5444,8 +5533,8 @@
         </p:nvSpPr>
         <p:spPr>
           <a:xfrm>
-            <a:off x="5320953" y="4488688"/>
-            <a:ext cx="873995" cy="196596"/>
+            <a:off x="4989217" y="4488688"/>
+            <a:ext cx="1272078" cy="196596"/>
           </a:xfrm>
           <a:prstGeom prst="rect">
             <a:avLst/>
@@ -5483,8 +5572,8 @@
         </p:nvSpPr>
         <p:spPr>
           <a:xfrm>
-            <a:off x="6249812" y="4488688"/>
-            <a:ext cx="1006690" cy="196596"/>
+            <a:off x="6316159" y="4488688"/>
+            <a:ext cx="940342" cy="196596"/>
           </a:xfrm>
           <a:prstGeom prst="rect">
             <a:avLst/>
@@ -5546,7 +5635,7 @@
         <p:spPr>
           <a:xfrm>
             <a:off x="676656" y="4685284"/>
-            <a:ext cx="608607" cy="196596"/>
+            <a:ext cx="542260" cy="196596"/>
           </a:xfrm>
           <a:prstGeom prst="rect">
             <a:avLst/>
@@ -5584,8 +5673,8 @@
         </p:nvSpPr>
         <p:spPr>
           <a:xfrm>
-            <a:off x="1340127" y="4685284"/>
-            <a:ext cx="873995" cy="196596"/>
+            <a:off x="1273780" y="4685284"/>
+            <a:ext cx="807648" cy="196596"/>
           </a:xfrm>
           <a:prstGeom prst="rect">
             <a:avLst/>
@@ -5623,8 +5712,8 @@
         </p:nvSpPr>
         <p:spPr>
           <a:xfrm>
-            <a:off x="2268986" y="4685284"/>
-            <a:ext cx="1006690" cy="196596"/>
+            <a:off x="2136292" y="4685284"/>
+            <a:ext cx="940342" cy="196596"/>
           </a:xfrm>
           <a:prstGeom prst="rect">
             <a:avLst/>
@@ -5662,8 +5751,8 @@
         </p:nvSpPr>
         <p:spPr>
           <a:xfrm>
-            <a:off x="3330540" y="4685284"/>
-            <a:ext cx="873995" cy="196596"/>
+            <a:off x="3131498" y="4685284"/>
+            <a:ext cx="807648" cy="196596"/>
           </a:xfrm>
           <a:prstGeom prst="rect">
             <a:avLst/>
@@ -5701,8 +5790,8 @@
         </p:nvSpPr>
         <p:spPr>
           <a:xfrm>
-            <a:off x="4259399" y="4685284"/>
-            <a:ext cx="1006690" cy="196596"/>
+            <a:off x="3994011" y="4685284"/>
+            <a:ext cx="940342" cy="196596"/>
           </a:xfrm>
           <a:prstGeom prst="rect">
             <a:avLst/>
@@ -5740,8 +5829,8 @@
         </p:nvSpPr>
         <p:spPr>
           <a:xfrm>
-            <a:off x="5320953" y="4685284"/>
-            <a:ext cx="873995" cy="196596"/>
+            <a:off x="4989217" y="4685284"/>
+            <a:ext cx="1272078" cy="196596"/>
           </a:xfrm>
           <a:prstGeom prst="rect">
             <a:avLst/>
@@ -5779,8 +5868,8 @@
         </p:nvSpPr>
         <p:spPr>
           <a:xfrm>
-            <a:off x="6249812" y="4685284"/>
-            <a:ext cx="1006690" cy="196596"/>
+            <a:off x="6316159" y="4685284"/>
+            <a:ext cx="940342" cy="196596"/>
           </a:xfrm>
           <a:prstGeom prst="rect">
             <a:avLst/>
@@ -5842,7 +5931,7 @@
         <p:spPr>
           <a:xfrm>
             <a:off x="676656" y="4881880"/>
-            <a:ext cx="608607" cy="196596"/>
+            <a:ext cx="542260" cy="196596"/>
           </a:xfrm>
           <a:prstGeom prst="rect">
             <a:avLst/>
@@ -5880,8 +5969,8 @@
         </p:nvSpPr>
         <p:spPr>
           <a:xfrm>
-            <a:off x="1340127" y="4881880"/>
-            <a:ext cx="873995" cy="196596"/>
+            <a:off x="1273780" y="4881880"/>
+            <a:ext cx="807648" cy="196596"/>
           </a:xfrm>
           <a:prstGeom prst="rect">
             <a:avLst/>
@@ -5919,8 +6008,8 @@
         </p:nvSpPr>
         <p:spPr>
           <a:xfrm>
-            <a:off x="2268986" y="4881880"/>
-            <a:ext cx="1006690" cy="196596"/>
+            <a:off x="2136292" y="4881880"/>
+            <a:ext cx="940342" cy="196596"/>
           </a:xfrm>
           <a:prstGeom prst="rect">
             <a:avLst/>
@@ -5958,8 +6047,8 @@
         </p:nvSpPr>
         <p:spPr>
           <a:xfrm>
-            <a:off x="3330540" y="4881880"/>
-            <a:ext cx="873995" cy="196596"/>
+            <a:off x="3131498" y="4881880"/>
+            <a:ext cx="807648" cy="196596"/>
           </a:xfrm>
           <a:prstGeom prst="rect">
             <a:avLst/>
@@ -5997,8 +6086,8 @@
         </p:nvSpPr>
         <p:spPr>
           <a:xfrm>
-            <a:off x="4259399" y="4881880"/>
-            <a:ext cx="1006690" cy="196596"/>
+            <a:off x="3994011" y="4881880"/>
+            <a:ext cx="940342" cy="196596"/>
           </a:xfrm>
           <a:prstGeom prst="rect">
             <a:avLst/>
@@ -6036,8 +6125,8 @@
         </p:nvSpPr>
         <p:spPr>
           <a:xfrm>
-            <a:off x="5320953" y="4881880"/>
-            <a:ext cx="873995" cy="196596"/>
+            <a:off x="4989217" y="4881880"/>
+            <a:ext cx="1272078" cy="196596"/>
           </a:xfrm>
           <a:prstGeom prst="rect">
             <a:avLst/>
@@ -6075,8 +6164,8 @@
         </p:nvSpPr>
         <p:spPr>
           <a:xfrm>
-            <a:off x="6249812" y="4881880"/>
-            <a:ext cx="1006690" cy="196596"/>
+            <a:off x="6316159" y="4881880"/>
+            <a:ext cx="940342" cy="196596"/>
           </a:xfrm>
           <a:prstGeom prst="rect">
             <a:avLst/>
@@ -6138,7 +6227,7 @@
         <p:spPr>
           <a:xfrm>
             <a:off x="676656" y="5078476"/>
-            <a:ext cx="608607" cy="196596"/>
+            <a:ext cx="542260" cy="196596"/>
           </a:xfrm>
           <a:prstGeom prst="rect">
             <a:avLst/>
@@ -6176,8 +6265,8 @@
         </p:nvSpPr>
         <p:spPr>
           <a:xfrm>
-            <a:off x="1340127" y="5078476"/>
-            <a:ext cx="873995" cy="196596"/>
+            <a:off x="1273780" y="5078476"/>
+            <a:ext cx="807648" cy="196596"/>
           </a:xfrm>
           <a:prstGeom prst="rect">
             <a:avLst/>
@@ -6215,8 +6304,8 @@
         </p:nvSpPr>
         <p:spPr>
           <a:xfrm>
-            <a:off x="2268986" y="5078476"/>
-            <a:ext cx="1006690" cy="196596"/>
+            <a:off x="2136292" y="5078476"/>
+            <a:ext cx="940342" cy="196596"/>
           </a:xfrm>
           <a:prstGeom prst="rect">
             <a:avLst/>
@@ -6254,8 +6343,8 @@
         </p:nvSpPr>
         <p:spPr>
           <a:xfrm>
-            <a:off x="3330540" y="5078476"/>
-            <a:ext cx="873995" cy="196596"/>
+            <a:off x="3131498" y="5078476"/>
+            <a:ext cx="807648" cy="196596"/>
           </a:xfrm>
           <a:prstGeom prst="rect">
             <a:avLst/>
@@ -6293,8 +6382,8 @@
         </p:nvSpPr>
         <p:spPr>
           <a:xfrm>
-            <a:off x="4259399" y="5078476"/>
-            <a:ext cx="1006690" cy="196596"/>
+            <a:off x="3994011" y="5078476"/>
+            <a:ext cx="940342" cy="196596"/>
           </a:xfrm>
           <a:prstGeom prst="rect">
             <a:avLst/>
@@ -6332,8 +6421,8 @@
         </p:nvSpPr>
         <p:spPr>
           <a:xfrm>
-            <a:off x="5320953" y="5078476"/>
-            <a:ext cx="873995" cy="196596"/>
+            <a:off x="4989217" y="5078476"/>
+            <a:ext cx="1272078" cy="196596"/>
           </a:xfrm>
           <a:prstGeom prst="rect">
             <a:avLst/>
@@ -6371,8 +6460,8 @@
         </p:nvSpPr>
         <p:spPr>
           <a:xfrm>
-            <a:off x="6249812" y="5078476"/>
-            <a:ext cx="1006690" cy="196596"/>
+            <a:off x="6316159" y="5078476"/>
+            <a:ext cx="940342" cy="196596"/>
           </a:xfrm>
           <a:prstGeom prst="rect">
             <a:avLst/>
@@ -6434,7 +6523,7 @@
         <p:spPr>
           <a:xfrm>
             <a:off x="676656" y="5275072"/>
-            <a:ext cx="608607" cy="196596"/>
+            <a:ext cx="542260" cy="196596"/>
           </a:xfrm>
           <a:prstGeom prst="rect">
             <a:avLst/>
@@ -6472,8 +6561,8 @@
         </p:nvSpPr>
         <p:spPr>
           <a:xfrm>
-            <a:off x="1340127" y="5275072"/>
-            <a:ext cx="873995" cy="196596"/>
+            <a:off x="1273780" y="5275072"/>
+            <a:ext cx="807648" cy="196596"/>
           </a:xfrm>
           <a:prstGeom prst="rect">
             <a:avLst/>
@@ -6511,8 +6600,8 @@
         </p:nvSpPr>
         <p:spPr>
           <a:xfrm>
-            <a:off x="2268986" y="5275072"/>
-            <a:ext cx="1006690" cy="196596"/>
+            <a:off x="2136292" y="5275072"/>
+            <a:ext cx="940342" cy="196596"/>
           </a:xfrm>
           <a:prstGeom prst="rect">
             <a:avLst/>
@@ -6550,8 +6639,8 @@
         </p:nvSpPr>
         <p:spPr>
           <a:xfrm>
-            <a:off x="3330540" y="5275072"/>
-            <a:ext cx="873995" cy="196596"/>
+            <a:off x="3131498" y="5275072"/>
+            <a:ext cx="807648" cy="196596"/>
           </a:xfrm>
           <a:prstGeom prst="rect">
             <a:avLst/>
@@ -6589,8 +6678,8 @@
         </p:nvSpPr>
         <p:spPr>
           <a:xfrm>
-            <a:off x="4259399" y="5275072"/>
-            <a:ext cx="1006690" cy="196596"/>
+            <a:off x="3994011" y="5275072"/>
+            <a:ext cx="940342" cy="196596"/>
           </a:xfrm>
           <a:prstGeom prst="rect">
             <a:avLst/>
@@ -6628,8 +6717,8 @@
         </p:nvSpPr>
         <p:spPr>
           <a:xfrm>
-            <a:off x="5320953" y="5275072"/>
-            <a:ext cx="873995" cy="196596"/>
+            <a:off x="4989217" y="5275072"/>
+            <a:ext cx="1272078" cy="196596"/>
           </a:xfrm>
           <a:prstGeom prst="rect">
             <a:avLst/>
@@ -6653,7 +6742,7 @@
                 <a:ea typeface="Roboto" pitchFamily="34" charset="-122"/>
                 <a:cs typeface="Roboto" pitchFamily="34" charset="-120"/>
               </a:rPr>
-              <a:t>Papsel 2 (2,0+0)</a:t>
+              <a:t>Papua Selatan 2 (2,0+0)</a:t>
             </a:r>
             <a:endParaRPr lang="en-US" sz="800" dirty="0"/>
           </a:p>
@@ -6667,8 +6756,8 @@
         </p:nvSpPr>
         <p:spPr>
           <a:xfrm>
-            <a:off x="6249812" y="5275072"/>
-            <a:ext cx="1006690" cy="196596"/>
+            <a:off x="6316159" y="5275072"/>
+            <a:ext cx="940342" cy="196596"/>
           </a:xfrm>
           <a:prstGeom prst="rect">
             <a:avLst/>
@@ -6752,7 +6841,7 @@
         <p:spPr>
           <a:xfrm>
             <a:off x="676656" y="5471668"/>
-            <a:ext cx="608607" cy="196596"/>
+            <a:ext cx="542260" cy="196596"/>
           </a:xfrm>
           <a:prstGeom prst="rect">
             <a:avLst/>
@@ -6790,8 +6879,8 @@
         </p:nvSpPr>
         <p:spPr>
           <a:xfrm>
-            <a:off x="1340127" y="5471668"/>
-            <a:ext cx="873995" cy="196596"/>
+            <a:off x="1273780" y="5471668"/>
+            <a:ext cx="807648" cy="196596"/>
           </a:xfrm>
           <a:prstGeom prst="rect">
             <a:avLst/>
@@ -6829,8 +6918,8 @@
         </p:nvSpPr>
         <p:spPr>
           <a:xfrm>
-            <a:off x="2268986" y="5471668"/>
-            <a:ext cx="1006690" cy="196596"/>
+            <a:off x="2136292" y="5471668"/>
+            <a:ext cx="940342" cy="196596"/>
           </a:xfrm>
           <a:prstGeom prst="rect">
             <a:avLst/>
@@ -6868,8 +6957,8 @@
         </p:nvSpPr>
         <p:spPr>
           <a:xfrm>
-            <a:off x="3330540" y="5471668"/>
-            <a:ext cx="873995" cy="196596"/>
+            <a:off x="3131498" y="5471668"/>
+            <a:ext cx="807648" cy="196596"/>
           </a:xfrm>
           <a:prstGeom prst="rect">
             <a:avLst/>
@@ -6907,8 +6996,8 @@
         </p:nvSpPr>
         <p:spPr>
           <a:xfrm>
-            <a:off x="4259399" y="5471668"/>
-            <a:ext cx="1006690" cy="196596"/>
+            <a:off x="3994011" y="5471668"/>
+            <a:ext cx="940342" cy="196596"/>
           </a:xfrm>
           <a:prstGeom prst="rect">
             <a:avLst/>
@@ -6946,8 +7035,8 @@
         </p:nvSpPr>
         <p:spPr>
           <a:xfrm>
-            <a:off x="5320953" y="5471668"/>
-            <a:ext cx="873995" cy="196596"/>
+            <a:off x="4989217" y="5471668"/>
+            <a:ext cx="1272078" cy="196596"/>
           </a:xfrm>
           <a:prstGeom prst="rect">
             <a:avLst/>
@@ -6985,8 +7074,8 @@
         </p:nvSpPr>
         <p:spPr>
           <a:xfrm>
-            <a:off x="6249812" y="5471668"/>
-            <a:ext cx="1006690" cy="196596"/>
+            <a:off x="6316159" y="5471668"/>
+            <a:ext cx="940342" cy="196596"/>
           </a:xfrm>
           <a:prstGeom prst="rect">
             <a:avLst/>
@@ -11056,6 +11145,2962 @@
             <a:fld id="{F7021451-1387-4CA6-816F-3879F97B5CBC}" type="slidenum">
               <a:rPr b="1" lang="en-US"/>
               <a:t>2</a:t>
+            </a:fld>
+            <a:endParaRPr lang="en-US"/>
+          </a:p>
+        </p:txBody>
+      </p:sp>
+    </p:spTree>
+  </p:cSld>
+  <p:clrMapOvr>
+    <a:masterClrMapping/>
+  </p:clrMapOvr>
+</p:sld>
+</file>
+
+<file path=ppt/slides/slide3.xml><?xml version="1.0" encoding="utf-8"?>
+<p:sld xmlns:a="http://schemas.openxmlformats.org/drawingml/2006/main" xmlns:r="http://schemas.openxmlformats.org/officeDocument/2006/relationships" xmlns:p="http://schemas.openxmlformats.org/presentationml/2006/main">
+  <p:cSld name="Slide 3">
+    <p:spTree>
+      <p:nvGrpSpPr>
+        <p:cNvPr id="1" name=""/>
+        <p:cNvGrpSpPr/>
+        <p:nvPr/>
+      </p:nvGrpSpPr>
+      <p:grpSpPr>
+        <a:xfrm>
+          <a:off x="0" y="0"/>
+          <a:ext cx="0" cy="0"/>
+          <a:chOff x="0" y="0"/>
+          <a:chExt cx="0" cy="0"/>
+        </a:xfrm>
+      </p:grpSpPr>
+      <p:sp>
+        <p:nvSpPr>
+          <p:cNvPr id="2" name="Text 3"/>
+          <p:cNvSpPr/>
+          <p:nvPr>
+            <p:ph idx="104" type="title" hasCustomPrompt="1"/>
+          </p:nvPr>
+        </p:nvSpPr>
+        <p:spPr>
+          <a:xfrm>
+            <a:off x="548640" y="274320"/>
+            <a:ext cx="8174736" cy="822960"/>
+          </a:xfrm>
+          <a:prstGeom prst="rect">
+            <a:avLst/>
+          </a:prstGeom>
+          <a:noFill/>
+          <a:ln/>
+        </p:spPr>
+        <p:txBody>
+          <a:bodyPr wrap="square" lIns="0" tIns="0" rIns="0" bIns="0" rtlCol="0" anchor="b"/>
+          <a:lstStyle/>
+          <a:p>
+            <a:pPr algn="l" indent="0" marL="0">
+              <a:buNone/>
+            </a:pPr>
+            <a:r>
+              <a:rPr lang="en-US" sz="2200" b="1" dirty="0">
+                <a:solidFill>
+                  <a:srgbClr val="1A1A1A"/>
+                </a:solidFill>
+                <a:latin typeface="Roboto" pitchFamily="34" charset="0"/>
+                <a:ea typeface="Roboto" pitchFamily="34" charset="-122"/>
+                <a:cs typeface="Roboto" pitchFamily="34" charset="-120"/>
+              </a:rPr>
+              <a:t>Bukti dunia: penyemaian higroskopis paling banyak menambah sekitar </a:t>
+            </a:r>
+            <a:r>
+              <a:rPr lang="en-US" sz="2200" b="1" dirty="0">
+                <a:solidFill>
+                  <a:srgbClr val="D9600B"/>
+                </a:solidFill>
+                <a:latin typeface="Roboto" pitchFamily="34" charset="0"/>
+                <a:ea typeface="Roboto" pitchFamily="34" charset="-122"/>
+                <a:cs typeface="Roboto" pitchFamily="34" charset="-120"/>
+              </a:rPr>
+              <a:t>18%</a:t>
+            </a:r>
+            <a:r>
+              <a:rPr lang="en-US" sz="2200" b="1" dirty="0">
+                <a:solidFill>
+                  <a:srgbClr val="1A1A1A"/>
+                </a:solidFill>
+                <a:latin typeface="Roboto" pitchFamily="34" charset="0"/>
+                <a:ea typeface="Roboto" pitchFamily="34" charset="-122"/>
+                <a:cs typeface="Roboto" pitchFamily="34" charset="-120"/>
+              </a:rPr>
+              <a:t> hujan, dry ice untuk asap belum terbukti</a:t>
+            </a:r>
+            <a:endParaRPr lang="en-US" sz="2200" dirty="0"/>
+          </a:p>
+        </p:txBody>
+      </p:sp>
+      <p:sp>
+        <p:nvSpPr>
+          <p:cNvPr id="3" name="Shape 1"/>
+          <p:cNvSpPr/>
+          <p:nvPr/>
+        </p:nvSpPr>
+        <p:spPr>
+          <a:xfrm>
+            <a:off x="8842248" y="886968"/>
+            <a:ext cx="2359152" cy="228600"/>
+          </a:xfrm>
+          <a:prstGeom prst="roundRect">
+            <a:avLst>
+              <a:gd name="adj" fmla="val 50000"/>
+            </a:avLst>
+          </a:prstGeom>
+          <a:solidFill>
+            <a:srgbClr val="051C2C"/>
+          </a:solidFill>
+          <a:ln/>
+        </p:spPr>
+      </p:sp>
+      <p:sp>
+        <p:nvSpPr>
+          <p:cNvPr id="4" name="Text 2"/>
+          <p:cNvSpPr/>
+          <p:nvPr/>
+        </p:nvSpPr>
+        <p:spPr>
+          <a:xfrm>
+            <a:off x="8897112" y="886968"/>
+            <a:ext cx="2249424" cy="228600"/>
+          </a:xfrm>
+          <a:prstGeom prst="rect">
+            <a:avLst/>
+          </a:prstGeom>
+          <a:noFill/>
+          <a:ln/>
+        </p:spPr>
+        <p:txBody>
+          <a:bodyPr wrap="square" lIns="0" tIns="0" rIns="0" bIns="0" rtlCol="0" anchor="ctr"/>
+          <a:lstStyle/>
+          <a:p>
+            <a:pPr algn="ctr" indent="0" marL="0">
+              <a:buNone/>
+            </a:pPr>
+            <a:endParaRPr lang="en-US" sz="800" dirty="0"/>
+          </a:p>
+        </p:txBody>
+      </p:sp>
+      <p:sp>
+        <p:nvSpPr>
+          <p:cNvPr id="5" name="Text 3"/>
+          <p:cNvSpPr/>
+          <p:nvPr/>
+        </p:nvSpPr>
+        <p:spPr>
+          <a:xfrm>
+            <a:off x="8842248" y="886968"/>
+            <a:ext cx="2359152" cy="228600"/>
+          </a:xfrm>
+          <a:prstGeom prst="rect">
+            <a:avLst/>
+          </a:prstGeom>
+          <a:noFill/>
+          <a:ln/>
+        </p:spPr>
+        <p:txBody>
+          <a:bodyPr wrap="square" lIns="0" tIns="0" rIns="0" bIns="0" rtlCol="0" anchor="ctr"/>
+          <a:lstStyle/>
+          <a:p>
+            <a:pPr algn="ctr" indent="0" marL="0">
+              <a:buNone/>
+            </a:pPr>
+            <a:r>
+              <a:rPr lang="en-US" sz="800" b="1" spc="100" kern="0" dirty="0">
+                <a:solidFill>
+                  <a:srgbClr val="AFC3DA"/>
+                </a:solidFill>
+                <a:latin typeface="Roboto" pitchFamily="34" charset="0"/>
+                <a:ea typeface="Roboto" pitchFamily="34" charset="-122"/>
+                <a:cs typeface="Roboto" pitchFamily="34" charset="-120"/>
+              </a:rPr>
+              <a:t>CUT OFF DATA</a:t>
+            </a:r>
+            <a:r>
+              <a:rPr lang="en-US" sz="900" dirty="0">
+                <a:solidFill>
+                  <a:srgbClr val="FFFFFF"/>
+                </a:solidFill>
+                <a:latin typeface="Roboto" pitchFamily="34" charset="0"/>
+                <a:ea typeface="Roboto" pitchFamily="34" charset="-122"/>
+                <a:cs typeface="Roboto" pitchFamily="34" charset="-120"/>
+              </a:rPr>
+              <a:t> </a:t>
+            </a:r>
+            <a:r>
+              <a:rPr lang="en-US" sz="900" b="1" dirty="0">
+                <a:solidFill>
+                  <a:srgbClr val="FFFFFF"/>
+                </a:solidFill>
+                <a:latin typeface="Roboto" pitchFamily="34" charset="0"/>
+                <a:ea typeface="Roboto" pitchFamily="34" charset="-122"/>
+                <a:cs typeface="Roboto" pitchFamily="34" charset="-120"/>
+              </a:rPr>
+              <a:t>27 Okt 2026</a:t>
+            </a:r>
+            <a:endParaRPr lang="en-US" sz="800" dirty="0"/>
+          </a:p>
+        </p:txBody>
+      </p:sp>
+      <p:sp>
+        <p:nvSpPr>
+          <p:cNvPr id="6" name="Shape 4"/>
+          <p:cNvSpPr/>
+          <p:nvPr/>
+        </p:nvSpPr>
+        <p:spPr>
+          <a:xfrm>
+            <a:off x="548640" y="6181344"/>
+            <a:ext cx="36576" cy="164592"/>
+          </a:xfrm>
+          <a:prstGeom prst="rect">
+            <a:avLst/>
+          </a:prstGeom>
+          <a:solidFill>
+            <a:srgbClr val="4A9BE0"/>
+          </a:solidFill>
+          <a:ln/>
+        </p:spPr>
+      </p:sp>
+      <p:sp>
+        <p:nvSpPr>
+          <p:cNvPr id="7" name="Text 5"/>
+          <p:cNvSpPr/>
+          <p:nvPr/>
+        </p:nvSpPr>
+        <p:spPr>
+          <a:xfrm>
+            <a:off x="640080" y="6163056"/>
+            <a:ext cx="11000232" cy="201168"/>
+          </a:xfrm>
+          <a:prstGeom prst="rect">
+            <a:avLst/>
+          </a:prstGeom>
+          <a:noFill/>
+          <a:ln/>
+        </p:spPr>
+        <p:txBody>
+          <a:bodyPr wrap="square" lIns="0" tIns="0" rIns="0" bIns="0" rtlCol="0" anchor="ctr"/>
+          <a:lstStyle/>
+          <a:p>
+            <a:pPr indent="0" marL="0">
+              <a:buNone/>
+            </a:pPr>
+            <a:r>
+              <a:rPr lang="en-US" sz="800" dirty="0">
+                <a:solidFill>
+                  <a:srgbClr val="6B7280"/>
+                </a:solidFill>
+                <a:latin typeface="Roboto" pitchFamily="34" charset="0"/>
+                <a:ea typeface="Roboto" pitchFamily="34" charset="-122"/>
+                <a:cs typeface="Roboto" pitchFamily="34" charset="-120"/>
+              </a:rPr>
+              <a:t>Sumber: WMO 2025; IITM 2023 (CAIPEEX-IV); Israel-4; Silverman 2003; BRIN 19 Okt 2026; BMKG Jul 2025; BNPB 21 Okt 2026. Angka CAIPEEX-IV dari siaran IITM; kebutuhan sampel adalah perkiraan kasar hitungan sendiri</a:t>
+            </a:r>
+            <a:endParaRPr lang="en-US" sz="800" dirty="0"/>
+          </a:p>
+        </p:txBody>
+      </p:sp>
+      <p:sp>
+        <p:nvSpPr>
+          <p:cNvPr id="8" name="Shape 6"/>
+          <p:cNvSpPr/>
+          <p:nvPr/>
+        </p:nvSpPr>
+        <p:spPr>
+          <a:xfrm>
+            <a:off x="548640" y="1280160"/>
+            <a:ext cx="3852756" cy="4809744"/>
+          </a:xfrm>
+          <a:prstGeom prst="roundRect">
+            <a:avLst>
+              <a:gd name="adj" fmla="val 1424"/>
+            </a:avLst>
+          </a:prstGeom>
+          <a:solidFill>
+            <a:srgbClr val="FFFFFF"/>
+          </a:solidFill>
+          <a:ln w="9525">
+            <a:solidFill>
+              <a:srgbClr val="D5DAE1"/>
+            </a:solidFill>
+            <a:prstDash val="solid"/>
+          </a:ln>
+        </p:spPr>
+      </p:sp>
+      <p:sp>
+        <p:nvSpPr>
+          <p:cNvPr id="9" name="Shape 7"/>
+          <p:cNvSpPr/>
+          <p:nvPr/>
+        </p:nvSpPr>
+        <p:spPr>
+          <a:xfrm>
+            <a:off x="548640" y="1280160"/>
+            <a:ext cx="3852756" cy="457200"/>
+          </a:xfrm>
+          <a:prstGeom prst="roundRect">
+            <a:avLst>
+              <a:gd name="adj" fmla="val 12000"/>
+            </a:avLst>
+          </a:prstGeom>
+          <a:solidFill>
+            <a:srgbClr val="E6EAF0"/>
+          </a:solidFill>
+          <a:ln/>
+        </p:spPr>
+      </p:sp>
+      <p:sp>
+        <p:nvSpPr>
+          <p:cNvPr id="10" name="Shape 8"/>
+          <p:cNvSpPr/>
+          <p:nvPr/>
+        </p:nvSpPr>
+        <p:spPr>
+          <a:xfrm>
+            <a:off x="548640" y="1508760"/>
+            <a:ext cx="3852756" cy="228600"/>
+          </a:xfrm>
+          <a:prstGeom prst="rect">
+            <a:avLst/>
+          </a:prstGeom>
+          <a:solidFill>
+            <a:srgbClr val="E6EAF0"/>
+          </a:solidFill>
+          <a:ln/>
+        </p:spPr>
+      </p:sp>
+      <p:sp>
+        <p:nvSpPr>
+          <p:cNvPr id="11" name="Shape 9"/>
+          <p:cNvSpPr/>
+          <p:nvPr/>
+        </p:nvSpPr>
+        <p:spPr>
+          <a:xfrm>
+            <a:off x="676656" y="1362456"/>
+            <a:ext cx="292608" cy="292608"/>
+          </a:xfrm>
+          <a:prstGeom prst="ellipse">
+            <a:avLst/>
+          </a:prstGeom>
+          <a:solidFill>
+            <a:srgbClr val="051C2C"/>
+          </a:solidFill>
+          <a:ln/>
+        </p:spPr>
+      </p:sp>
+      <p:pic>
+        <p:nvPicPr>
+          <p:cNvPr id="12" name="Image 0" descr="/Users/priyankaalfatehan28/.claude/skills/ppt-konsultan/mesin/cache-ikon/flask-regular-FFFFFF.png">    </p:cNvPr>
+          <p:cNvPicPr>
+            <a:picLocks noChangeAspect="1"/>
+          </p:cNvPicPr>
+          <p:nvPr/>
+        </p:nvPicPr>
+        <p:blipFill>
+          <a:blip r:embed="rId1"/>
+          <a:stretch>
+            <a:fillRect/>
+          </a:stretch>
+        </p:blipFill>
+        <p:spPr>
+          <a:xfrm>
+            <a:off x="740664" y="1426464"/>
+            <a:ext cx="164592" cy="164592"/>
+          </a:xfrm>
+          <a:prstGeom prst="rect">
+            <a:avLst/>
+          </a:prstGeom>
+        </p:spPr>
+      </p:pic>
+      <p:sp>
+        <p:nvSpPr>
+          <p:cNvPr id="13" name="Text 10"/>
+          <p:cNvSpPr/>
+          <p:nvPr/>
+        </p:nvSpPr>
+        <p:spPr>
+          <a:xfrm>
+            <a:off x="1060704" y="1280160"/>
+            <a:ext cx="3203532" cy="457200"/>
+          </a:xfrm>
+          <a:prstGeom prst="rect">
+            <a:avLst/>
+          </a:prstGeom>
+          <a:noFill/>
+          <a:ln/>
+        </p:spPr>
+        <p:txBody>
+          <a:bodyPr wrap="square" lIns="0" tIns="0" rIns="0" bIns="0" rtlCol="0" anchor="ctr"/>
+          <a:lstStyle/>
+          <a:p>
+            <a:pPr indent="0" marL="0">
+              <a:buNone/>
+            </a:pPr>
+            <a:r>
+              <a:rPr lang="en-US" sz="1000" b="1" dirty="0">
+                <a:solidFill>
+                  <a:srgbClr val="1A1A1A"/>
+                </a:solidFill>
+                <a:latin typeface="Roboto" pitchFamily="34" charset="0"/>
+                <a:ea typeface="Roboto" pitchFamily="34" charset="-122"/>
+                <a:cs typeface="Roboto" pitchFamily="34" charset="-120"/>
+              </a:rPr>
+              <a:t>Bukti studi penyemaian awan</a:t>
+            </a:r>
+            <a:endParaRPr lang="en-US" sz="1000" dirty="0"/>
+          </a:p>
+        </p:txBody>
+      </p:sp>
+      <p:sp>
+        <p:nvSpPr>
+          <p:cNvPr id="14" name="Text 11"/>
+          <p:cNvSpPr/>
+          <p:nvPr/>
+        </p:nvSpPr>
+        <p:spPr>
+          <a:xfrm>
+            <a:off x="676656" y="1828800"/>
+            <a:ext cx="808350" cy="182880"/>
+          </a:xfrm>
+          <a:prstGeom prst="rect">
+            <a:avLst/>
+          </a:prstGeom>
+          <a:noFill/>
+          <a:ln/>
+        </p:spPr>
+        <p:txBody>
+          <a:bodyPr wrap="square" lIns="0" tIns="0" rIns="0" bIns="0" rtlCol="0" anchor="ctr"/>
+          <a:lstStyle/>
+          <a:p>
+            <a:pPr algn="ctr" indent="0" marL="0">
+              <a:buNone/>
+            </a:pPr>
+            <a:r>
+              <a:rPr lang="en-US" sz="800" b="1" spc="150" kern="0" dirty="0">
+                <a:solidFill>
+                  <a:srgbClr val="6B7280"/>
+                </a:solidFill>
+                <a:latin typeface="Roboto" pitchFamily="34" charset="0"/>
+                <a:ea typeface="Roboto" pitchFamily="34" charset="-122"/>
+                <a:cs typeface="Roboto" pitchFamily="34" charset="-120"/>
+              </a:rPr>
+              <a:t>STUDI</a:t>
+            </a:r>
+            <a:endParaRPr lang="en-US" sz="800" dirty="0"/>
+          </a:p>
+        </p:txBody>
+      </p:sp>
+      <p:sp>
+        <p:nvSpPr>
+          <p:cNvPr id="15" name="Text 12"/>
+          <p:cNvSpPr/>
+          <p:nvPr/>
+        </p:nvSpPr>
+        <p:spPr>
+          <a:xfrm>
+            <a:off x="1539870" y="1828800"/>
+            <a:ext cx="1239956" cy="182880"/>
+          </a:xfrm>
+          <a:prstGeom prst="rect">
+            <a:avLst/>
+          </a:prstGeom>
+          <a:noFill/>
+          <a:ln/>
+        </p:spPr>
+        <p:txBody>
+          <a:bodyPr wrap="square" lIns="0" tIns="0" rIns="0" bIns="0" rtlCol="0" anchor="ctr"/>
+          <a:lstStyle/>
+          <a:p>
+            <a:pPr algn="ctr" indent="0" marL="0">
+              <a:buNone/>
+            </a:pPr>
+            <a:r>
+              <a:rPr lang="en-US" sz="800" b="1" spc="150" kern="0" dirty="0">
+                <a:solidFill>
+                  <a:srgbClr val="6B7280"/>
+                </a:solidFill>
+                <a:latin typeface="Roboto" pitchFamily="34" charset="0"/>
+                <a:ea typeface="Roboto" pitchFamily="34" charset="-122"/>
+                <a:cs typeface="Roboto" pitchFamily="34" charset="-120"/>
+              </a:rPr>
+              <a:t>HASIL</a:t>
+            </a:r>
+            <a:endParaRPr lang="en-US" sz="800" dirty="0"/>
+          </a:p>
+        </p:txBody>
+      </p:sp>
+      <p:sp>
+        <p:nvSpPr>
+          <p:cNvPr id="16" name="Text 13"/>
+          <p:cNvSpPr/>
+          <p:nvPr/>
+        </p:nvSpPr>
+        <p:spPr>
+          <a:xfrm>
+            <a:off x="2834690" y="1828800"/>
+            <a:ext cx="1383825" cy="182880"/>
+          </a:xfrm>
+          <a:prstGeom prst="rect">
+            <a:avLst/>
+          </a:prstGeom>
+          <a:noFill/>
+          <a:ln/>
+        </p:spPr>
+        <p:txBody>
+          <a:bodyPr wrap="square" lIns="0" tIns="0" rIns="0" bIns="0" rtlCol="0" anchor="ctr"/>
+          <a:lstStyle/>
+          <a:p>
+            <a:pPr algn="ctr" indent="0" marL="0">
+              <a:buNone/>
+            </a:pPr>
+            <a:r>
+              <a:rPr lang="en-US" sz="800" b="1" spc="150" kern="0" dirty="0">
+                <a:solidFill>
+                  <a:srgbClr val="6B7280"/>
+                </a:solidFill>
+                <a:latin typeface="Roboto" pitchFamily="34" charset="0"/>
+                <a:ea typeface="Roboto" pitchFamily="34" charset="-122"/>
+                <a:cs typeface="Roboto" pitchFamily="34" charset="-120"/>
+              </a:rPr>
+              <a:t>CATATAN</a:t>
+            </a:r>
+            <a:endParaRPr lang="en-US" sz="800" dirty="0"/>
+          </a:p>
+        </p:txBody>
+      </p:sp>
+      <p:sp>
+        <p:nvSpPr>
+          <p:cNvPr id="17" name="Shape 14"/>
+          <p:cNvSpPr/>
+          <p:nvPr/>
+        </p:nvSpPr>
+        <p:spPr>
+          <a:xfrm>
+            <a:off x="676656" y="2057400"/>
+            <a:ext cx="3596724" cy="0"/>
+          </a:xfrm>
+          <a:prstGeom prst="line">
+            <a:avLst/>
+          </a:prstGeom>
+          <a:noFill/>
+          <a:ln w="9525">
+            <a:solidFill>
+              <a:srgbClr val="1A1A1A"/>
+            </a:solidFill>
+            <a:prstDash val="solid"/>
+          </a:ln>
+        </p:spPr>
+      </p:sp>
+      <p:sp>
+        <p:nvSpPr>
+          <p:cNvPr id="18" name="Text 15"/>
+          <p:cNvSpPr/>
+          <p:nvPr/>
+        </p:nvSpPr>
+        <p:spPr>
+          <a:xfrm>
+            <a:off x="676656" y="2057400"/>
+            <a:ext cx="808350" cy="731520"/>
+          </a:xfrm>
+          <a:prstGeom prst="rect">
+            <a:avLst/>
+          </a:prstGeom>
+          <a:noFill/>
+          <a:ln/>
+        </p:spPr>
+        <p:txBody>
+          <a:bodyPr wrap="square" lIns="0" tIns="0" rIns="0" bIns="0" rtlCol="0" anchor="ctr"/>
+          <a:lstStyle/>
+          <a:p>
+            <a:pPr algn="l" indent="0" marL="0">
+              <a:buNone/>
+            </a:pPr>
+            <a:r>
+              <a:rPr lang="en-US" sz="800" b="1" dirty="0">
+                <a:solidFill>
+                  <a:srgbClr val="1A1A1A"/>
+                </a:solidFill>
+                <a:latin typeface="Roboto" pitchFamily="34" charset="0"/>
+                <a:ea typeface="Roboto" pitchFamily="34" charset="-122"/>
+                <a:cs typeface="Roboto" pitchFamily="34" charset="-120"/>
+              </a:rPr>
+              <a:t>WMO 2025</a:t>
+            </a:r>
+            <a:endParaRPr lang="en-US" sz="800" dirty="0"/>
+          </a:p>
+        </p:txBody>
+      </p:sp>
+      <p:sp>
+        <p:nvSpPr>
+          <p:cNvPr id="19" name="Text 16"/>
+          <p:cNvSpPr/>
+          <p:nvPr/>
+        </p:nvSpPr>
+        <p:spPr>
+          <a:xfrm>
+            <a:off x="1539870" y="2057400"/>
+            <a:ext cx="1239956" cy="731520"/>
+          </a:xfrm>
+          <a:prstGeom prst="rect">
+            <a:avLst/>
+          </a:prstGeom>
+          <a:noFill/>
+          <a:ln/>
+        </p:spPr>
+        <p:txBody>
+          <a:bodyPr wrap="square" lIns="0" tIns="0" rIns="0" bIns="0" rtlCol="0" anchor="ctr"/>
+          <a:lstStyle/>
+          <a:p>
+            <a:pPr algn="l" indent="0" marL="0">
+              <a:buNone/>
+            </a:pPr>
+            <a:r>
+              <a:rPr lang="en-US" sz="800" dirty="0">
+                <a:solidFill>
+                  <a:srgbClr val="2E3440"/>
+                </a:solidFill>
+                <a:latin typeface="Roboto" pitchFamily="34" charset="0"/>
+                <a:ea typeface="Roboto" pitchFamily="34" charset="-122"/>
+                <a:cs typeface="Roboto" pitchFamily="34" charset="-120"/>
+              </a:rPr>
+              <a:t>Tanpa angka persen; bukti sebab-akibat kuat hanya untuk glasiogenik awan orografik musim dingin</a:t>
+            </a:r>
+            <a:endParaRPr lang="en-US" sz="800" dirty="0"/>
+          </a:p>
+        </p:txBody>
+      </p:sp>
+      <p:sp>
+        <p:nvSpPr>
+          <p:cNvPr id="20" name="Text 17"/>
+          <p:cNvSpPr/>
+          <p:nvPr/>
+        </p:nvSpPr>
+        <p:spPr>
+          <a:xfrm>
+            <a:off x="2834690" y="2057400"/>
+            <a:ext cx="1383825" cy="731520"/>
+          </a:xfrm>
+          <a:prstGeom prst="rect">
+            <a:avLst/>
+          </a:prstGeom>
+          <a:noFill/>
+          <a:ln/>
+        </p:spPr>
+        <p:txBody>
+          <a:bodyPr wrap="square" lIns="0" tIns="0" rIns="0" bIns="0" rtlCol="0" anchor="ctr"/>
+          <a:lstStyle/>
+          <a:p>
+            <a:pPr algn="l" indent="0" marL="0">
+              <a:buNone/>
+            </a:pPr>
+            <a:r>
+              <a:rPr lang="en-US" sz="800" dirty="0">
+                <a:solidFill>
+                  <a:srgbClr val="2E3440"/>
+                </a:solidFill>
+                <a:latin typeface="Roboto" pitchFamily="34" charset="0"/>
+                <a:ea typeface="Roboto" pitchFamily="34" charset="-122"/>
+                <a:cs typeface="Roboto" pitchFamily="34" charset="-120"/>
+              </a:rPr>
+              <a:t>Awan konvektif bersinyal lemah; hasil satu uji tidak langsung berlaku di tempat lain.</a:t>
+            </a:r>
+            <a:endParaRPr lang="en-US" sz="800" dirty="0"/>
+          </a:p>
+        </p:txBody>
+      </p:sp>
+      <p:sp>
+        <p:nvSpPr>
+          <p:cNvPr id="21" name="Shape 18"/>
+          <p:cNvSpPr/>
+          <p:nvPr/>
+        </p:nvSpPr>
+        <p:spPr>
+          <a:xfrm>
+            <a:off x="676656" y="2788920"/>
+            <a:ext cx="3596724" cy="0"/>
+          </a:xfrm>
+          <a:prstGeom prst="line">
+            <a:avLst/>
+          </a:prstGeom>
+          <a:noFill/>
+          <a:ln w="6350">
+            <a:solidFill>
+              <a:srgbClr val="E3E6EA"/>
+            </a:solidFill>
+            <a:prstDash val="solid"/>
+          </a:ln>
+        </p:spPr>
+      </p:sp>
+      <p:sp>
+        <p:nvSpPr>
+          <p:cNvPr id="22" name="Text 19"/>
+          <p:cNvSpPr/>
+          <p:nvPr/>
+        </p:nvSpPr>
+        <p:spPr>
+          <a:xfrm>
+            <a:off x="676656" y="2788920"/>
+            <a:ext cx="808350" cy="731520"/>
+          </a:xfrm>
+          <a:prstGeom prst="rect">
+            <a:avLst/>
+          </a:prstGeom>
+          <a:noFill/>
+          <a:ln/>
+        </p:spPr>
+        <p:txBody>
+          <a:bodyPr wrap="square" lIns="0" tIns="0" rIns="0" bIns="0" rtlCol="0" anchor="ctr"/>
+          <a:lstStyle/>
+          <a:p>
+            <a:pPr algn="l" indent="0" marL="0">
+              <a:buNone/>
+            </a:pPr>
+            <a:r>
+              <a:rPr lang="en-US" sz="800" b="1" dirty="0">
+                <a:solidFill>
+                  <a:srgbClr val="1A1A1A"/>
+                </a:solidFill>
+                <a:latin typeface="Roboto" pitchFamily="34" charset="0"/>
+                <a:ea typeface="Roboto" pitchFamily="34" charset="-122"/>
+                <a:cs typeface="Roboto" pitchFamily="34" charset="-120"/>
+              </a:rPr>
+              <a:t>CAIPEEX-IV India 2023</a:t>
+            </a:r>
+            <a:endParaRPr lang="en-US" sz="800" dirty="0"/>
+          </a:p>
+        </p:txBody>
+      </p:sp>
+      <p:sp>
+        <p:nvSpPr>
+          <p:cNvPr id="23" name="Text 20"/>
+          <p:cNvSpPr/>
+          <p:nvPr/>
+        </p:nvSpPr>
+        <p:spPr>
+          <a:xfrm>
+            <a:off x="1539870" y="2788920"/>
+            <a:ext cx="1239956" cy="731520"/>
+          </a:xfrm>
+          <a:prstGeom prst="rect">
+            <a:avLst/>
+          </a:prstGeom>
+          <a:noFill/>
+          <a:ln/>
+        </p:spPr>
+        <p:txBody>
+          <a:bodyPr wrap="square" lIns="0" tIns="0" rIns="0" bIns="0" rtlCol="0" anchor="ctr"/>
+          <a:lstStyle/>
+          <a:p>
+            <a:pPr algn="l" indent="0" marL="0">
+              <a:buNone/>
+            </a:pPr>
+            <a:r>
+              <a:rPr lang="en-US" sz="800" dirty="0">
+                <a:solidFill>
+                  <a:srgbClr val="2E3440"/>
+                </a:solidFill>
+                <a:latin typeface="Roboto" pitchFamily="34" charset="0"/>
+                <a:ea typeface="Roboto" pitchFamily="34" charset="-122"/>
+                <a:cs typeface="Roboto" pitchFamily="34" charset="-120"/>
+              </a:rPr>
+              <a:t>+18 ±2,6% hujan rata-rata di area 100 km2 hilir</a:t>
+            </a:r>
+            <a:endParaRPr lang="en-US" sz="800" dirty="0"/>
+          </a:p>
+        </p:txBody>
+      </p:sp>
+      <p:sp>
+        <p:nvSpPr>
+          <p:cNvPr id="24" name="Text 21"/>
+          <p:cNvSpPr/>
+          <p:nvPr/>
+        </p:nvSpPr>
+        <p:spPr>
+          <a:xfrm>
+            <a:off x="2834690" y="2788920"/>
+            <a:ext cx="1383825" cy="731520"/>
+          </a:xfrm>
+          <a:prstGeom prst="rect">
+            <a:avLst/>
+          </a:prstGeom>
+          <a:noFill/>
+          <a:ln/>
+        </p:spPr>
+        <p:txBody>
+          <a:bodyPr wrap="square" lIns="0" tIns="0" rIns="0" bIns="0" rtlCol="0" anchor="ctr"/>
+          <a:lstStyle/>
+          <a:p>
+            <a:pPr algn="l" indent="0" marL="0">
+              <a:buNone/>
+            </a:pPr>
+            <a:r>
+              <a:rPr lang="en-US" sz="800" dirty="0">
+                <a:solidFill>
+                  <a:srgbClr val="2E3440"/>
+                </a:solidFill>
+                <a:latin typeface="Roboto" pitchFamily="34" charset="0"/>
+                <a:ea typeface="Roboto" pitchFamily="34" charset="-122"/>
+                <a:cs typeface="Roboto" pitchFamily="34" charset="-120"/>
+              </a:rPr>
+              <a:t>Higroskopis, acak, 150 semai dan 122 tanpa semai; satu lokasi di bayangan hujan Ghats Barat.</a:t>
+            </a:r>
+            <a:endParaRPr lang="en-US" sz="800" dirty="0"/>
+          </a:p>
+        </p:txBody>
+      </p:sp>
+      <p:sp>
+        <p:nvSpPr>
+          <p:cNvPr id="25" name="Shape 22"/>
+          <p:cNvSpPr/>
+          <p:nvPr/>
+        </p:nvSpPr>
+        <p:spPr>
+          <a:xfrm>
+            <a:off x="676656" y="3520440"/>
+            <a:ext cx="3596724" cy="0"/>
+          </a:xfrm>
+          <a:prstGeom prst="line">
+            <a:avLst/>
+          </a:prstGeom>
+          <a:noFill/>
+          <a:ln w="6350">
+            <a:solidFill>
+              <a:srgbClr val="E3E6EA"/>
+            </a:solidFill>
+            <a:prstDash val="solid"/>
+          </a:ln>
+        </p:spPr>
+      </p:sp>
+      <p:sp>
+        <p:nvSpPr>
+          <p:cNvPr id="26" name="Text 23"/>
+          <p:cNvSpPr/>
+          <p:nvPr/>
+        </p:nvSpPr>
+        <p:spPr>
+          <a:xfrm>
+            <a:off x="676656" y="3520440"/>
+            <a:ext cx="808350" cy="731520"/>
+          </a:xfrm>
+          <a:prstGeom prst="rect">
+            <a:avLst/>
+          </a:prstGeom>
+          <a:noFill/>
+          <a:ln/>
+        </p:spPr>
+        <p:txBody>
+          <a:bodyPr wrap="square" lIns="0" tIns="0" rIns="0" bIns="0" rtlCol="0" anchor="ctr"/>
+          <a:lstStyle/>
+          <a:p>
+            <a:pPr algn="l" indent="0" marL="0">
+              <a:buNone/>
+            </a:pPr>
+            <a:r>
+              <a:rPr lang="en-US" sz="800" b="1" dirty="0">
+                <a:solidFill>
+                  <a:srgbClr val="1A1A1A"/>
+                </a:solidFill>
+                <a:latin typeface="Roboto" pitchFamily="34" charset="0"/>
+                <a:ea typeface="Roboto" pitchFamily="34" charset="-122"/>
+                <a:cs typeface="Roboto" pitchFamily="34" charset="-120"/>
+              </a:rPr>
+              <a:t>Israel-4 2013 sampai 2020</a:t>
+            </a:r>
+            <a:endParaRPr lang="en-US" sz="800" dirty="0"/>
+          </a:p>
+        </p:txBody>
+      </p:sp>
+      <p:sp>
+        <p:nvSpPr>
+          <p:cNvPr id="27" name="Text 24"/>
+          <p:cNvSpPr/>
+          <p:nvPr/>
+        </p:nvSpPr>
+        <p:spPr>
+          <a:xfrm>
+            <a:off x="1539870" y="3520440"/>
+            <a:ext cx="1239956" cy="731520"/>
+          </a:xfrm>
+          <a:prstGeom prst="rect">
+            <a:avLst/>
+          </a:prstGeom>
+          <a:noFill/>
+          <a:ln/>
+        </p:spPr>
+        <p:txBody>
+          <a:bodyPr wrap="square" lIns="0" tIns="0" rIns="0" bIns="0" rtlCol="0" anchor="ctr"/>
+          <a:lstStyle/>
+          <a:p>
+            <a:pPr algn="l" indent="0" marL="0">
+              <a:buNone/>
+            </a:pPr>
+            <a:r>
+              <a:rPr lang="en-US" sz="800" dirty="0">
+                <a:solidFill>
+                  <a:srgbClr val="2E3440"/>
+                </a:solidFill>
+                <a:latin typeface="Roboto" pitchFamily="34" charset="0"/>
+                <a:ea typeface="Roboto" pitchFamily="34" charset="-122"/>
+                <a:cs typeface="Roboto" pitchFamily="34" charset="-120"/>
+              </a:rPr>
+              <a:t>+1,8%, p = 0,4, selang 95% -11% sampai 16%</a:t>
+            </a:r>
+            <a:endParaRPr lang="en-US" sz="800" dirty="0"/>
+          </a:p>
+        </p:txBody>
+      </p:sp>
+      <p:sp>
+        <p:nvSpPr>
+          <p:cNvPr id="28" name="Text 25"/>
+          <p:cNvSpPr/>
+          <p:nvPr/>
+        </p:nvSpPr>
+        <p:spPr>
+          <a:xfrm>
+            <a:off x="2834690" y="3520440"/>
+            <a:ext cx="1383825" cy="731520"/>
+          </a:xfrm>
+          <a:prstGeom prst="rect">
+            <a:avLst/>
+          </a:prstGeom>
+          <a:noFill/>
+          <a:ln/>
+        </p:spPr>
+        <p:txBody>
+          <a:bodyPr wrap="square" lIns="0" tIns="0" rIns="0" bIns="0" rtlCol="0" anchor="ctr"/>
+          <a:lstStyle/>
+          <a:p>
+            <a:pPr algn="l" indent="0" marL="0">
+              <a:buNone/>
+            </a:pPr>
+            <a:r>
+              <a:rPr lang="en-US" sz="800" dirty="0">
+                <a:solidFill>
+                  <a:srgbClr val="2E3440"/>
+                </a:solidFill>
+                <a:latin typeface="Roboto" pitchFamily="34" charset="0"/>
+                <a:ea typeface="Roboto" pitchFamily="34" charset="-122"/>
+                <a:cs typeface="Roboto" pitchFamily="34" charset="-120"/>
+              </a:rPr>
+              <a:t>Uji acak dengan AgI; efek tidak terdeteksi.</a:t>
+            </a:r>
+            <a:endParaRPr lang="en-US" sz="800" dirty="0"/>
+          </a:p>
+        </p:txBody>
+      </p:sp>
+      <p:sp>
+        <p:nvSpPr>
+          <p:cNvPr id="29" name="Shape 26"/>
+          <p:cNvSpPr/>
+          <p:nvPr/>
+        </p:nvSpPr>
+        <p:spPr>
+          <a:xfrm>
+            <a:off x="676656" y="4251960"/>
+            <a:ext cx="3596724" cy="0"/>
+          </a:xfrm>
+          <a:prstGeom prst="line">
+            <a:avLst/>
+          </a:prstGeom>
+          <a:noFill/>
+          <a:ln w="6350">
+            <a:solidFill>
+              <a:srgbClr val="E3E6EA"/>
+            </a:solidFill>
+            <a:prstDash val="solid"/>
+          </a:ln>
+        </p:spPr>
+      </p:sp>
+      <p:sp>
+        <p:nvSpPr>
+          <p:cNvPr id="30" name="Text 27"/>
+          <p:cNvSpPr/>
+          <p:nvPr/>
+        </p:nvSpPr>
+        <p:spPr>
+          <a:xfrm>
+            <a:off x="676656" y="4251960"/>
+            <a:ext cx="808350" cy="731520"/>
+          </a:xfrm>
+          <a:prstGeom prst="rect">
+            <a:avLst/>
+          </a:prstGeom>
+          <a:noFill/>
+          <a:ln/>
+        </p:spPr>
+        <p:txBody>
+          <a:bodyPr wrap="square" lIns="0" tIns="0" rIns="0" bIns="0" rtlCol="0" anchor="ctr"/>
+          <a:lstStyle/>
+          <a:p>
+            <a:pPr algn="l" indent="0" marL="0">
+              <a:buNone/>
+            </a:pPr>
+            <a:r>
+              <a:rPr lang="en-US" sz="800" b="1" dirty="0">
+                <a:solidFill>
+                  <a:srgbClr val="1A1A1A"/>
+                </a:solidFill>
+                <a:latin typeface="Roboto" pitchFamily="34" charset="0"/>
+                <a:ea typeface="Roboto" pitchFamily="34" charset="-122"/>
+                <a:cs typeface="Roboto" pitchFamily="34" charset="-120"/>
+              </a:rPr>
+              <a:t>Silverman 2003</a:t>
+            </a:r>
+            <a:endParaRPr lang="en-US" sz="800" dirty="0"/>
+          </a:p>
+        </p:txBody>
+      </p:sp>
+      <p:sp>
+        <p:nvSpPr>
+          <p:cNvPr id="31" name="Text 28"/>
+          <p:cNvSpPr/>
+          <p:nvPr/>
+        </p:nvSpPr>
+        <p:spPr>
+          <a:xfrm>
+            <a:off x="1539870" y="4251960"/>
+            <a:ext cx="1239956" cy="731520"/>
+          </a:xfrm>
+          <a:prstGeom prst="rect">
+            <a:avLst/>
+          </a:prstGeom>
+          <a:noFill/>
+          <a:ln/>
+        </p:spPr>
+        <p:txBody>
+          <a:bodyPr wrap="square" lIns="0" tIns="0" rIns="0" bIns="0" rtlCol="0" anchor="ctr"/>
+          <a:lstStyle/>
+          <a:p>
+            <a:pPr algn="l" indent="0" marL="0">
+              <a:buNone/>
+            </a:pPr>
+            <a:r>
+              <a:rPr lang="en-US" sz="800" dirty="0">
+                <a:solidFill>
+                  <a:srgbClr val="2E3440"/>
+                </a:solidFill>
+                <a:latin typeface="Roboto" pitchFamily="34" charset="0"/>
+                <a:ea typeface="Roboto" pitchFamily="34" charset="-122"/>
+                <a:cs typeface="Roboto" pitchFamily="34" charset="-120"/>
+              </a:rPr>
+              <a:t>Empat uji higroskopis acak belum terbukti</a:t>
+            </a:r>
+            <a:endParaRPr lang="en-US" sz="800" dirty="0"/>
+          </a:p>
+        </p:txBody>
+      </p:sp>
+      <p:sp>
+        <p:nvSpPr>
+          <p:cNvPr id="32" name="Text 29"/>
+          <p:cNvSpPr/>
+          <p:nvPr/>
+        </p:nvSpPr>
+        <p:spPr>
+          <a:xfrm>
+            <a:off x="2834690" y="4251960"/>
+            <a:ext cx="1383825" cy="731520"/>
+          </a:xfrm>
+          <a:prstGeom prst="rect">
+            <a:avLst/>
+          </a:prstGeom>
+          <a:noFill/>
+          <a:ln/>
+        </p:spPr>
+        <p:txBody>
+          <a:bodyPr wrap="square" lIns="0" tIns="0" rIns="0" bIns="0" rtlCol="0" anchor="ctr"/>
+          <a:lstStyle/>
+          <a:p>
+            <a:pPr algn="l" indent="0" marL="0">
+              <a:buNone/>
+            </a:pPr>
+            <a:r>
+              <a:rPr lang="en-US" sz="800" dirty="0">
+                <a:solidFill>
+                  <a:srgbClr val="2E3440"/>
+                </a:solidFill>
+                <a:latin typeface="Roboto" pitchFamily="34" charset="0"/>
+                <a:ea typeface="Roboto" pitchFamily="34" charset="-122"/>
+                <a:cs typeface="Roboto" pitchFamily="34" charset="-120"/>
+              </a:rPr>
+              <a:t>Belum memberi bukti statistik maupun fisik.</a:t>
+            </a:r>
+            <a:endParaRPr lang="en-US" sz="800" dirty="0"/>
+          </a:p>
+        </p:txBody>
+      </p:sp>
+      <p:sp>
+        <p:nvSpPr>
+          <p:cNvPr id="33" name="Shape 30"/>
+          <p:cNvSpPr/>
+          <p:nvPr/>
+        </p:nvSpPr>
+        <p:spPr>
+          <a:xfrm>
+            <a:off x="676656" y="4983480"/>
+            <a:ext cx="3596724" cy="0"/>
+          </a:xfrm>
+          <a:prstGeom prst="line">
+            <a:avLst/>
+          </a:prstGeom>
+          <a:noFill/>
+          <a:ln w="6350">
+            <a:solidFill>
+              <a:srgbClr val="E3E6EA"/>
+            </a:solidFill>
+            <a:prstDash val="solid"/>
+          </a:ln>
+        </p:spPr>
+      </p:sp>
+      <p:sp>
+        <p:nvSpPr>
+          <p:cNvPr id="34" name="Text 31"/>
+          <p:cNvSpPr/>
+          <p:nvPr/>
+        </p:nvSpPr>
+        <p:spPr>
+          <a:xfrm>
+            <a:off x="676656" y="4983480"/>
+            <a:ext cx="808350" cy="731520"/>
+          </a:xfrm>
+          <a:prstGeom prst="rect">
+            <a:avLst/>
+          </a:prstGeom>
+          <a:noFill/>
+          <a:ln/>
+        </p:spPr>
+        <p:txBody>
+          <a:bodyPr wrap="square" lIns="0" tIns="0" rIns="0" bIns="0" rtlCol="0" anchor="ctr"/>
+          <a:lstStyle/>
+          <a:p>
+            <a:pPr algn="l" indent="0" marL="0">
+              <a:buNone/>
+            </a:pPr>
+            <a:r>
+              <a:rPr lang="en-US" sz="800" b="1" dirty="0">
+                <a:solidFill>
+                  <a:srgbClr val="1A1A1A"/>
+                </a:solidFill>
+                <a:latin typeface="Roboto" pitchFamily="34" charset="0"/>
+                <a:ea typeface="Roboto" pitchFamily="34" charset="-122"/>
+                <a:cs typeface="Roboto" pitchFamily="34" charset="-120"/>
+              </a:rPr>
+              <a:t>Dry ice untuk asap</a:t>
+            </a:r>
+            <a:endParaRPr lang="en-US" sz="800" dirty="0"/>
+          </a:p>
+        </p:txBody>
+      </p:sp>
+      <p:sp>
+        <p:nvSpPr>
+          <p:cNvPr id="35" name="Text 32"/>
+          <p:cNvSpPr/>
+          <p:nvPr/>
+        </p:nvSpPr>
+        <p:spPr>
+          <a:xfrm>
+            <a:off x="1539870" y="4983480"/>
+            <a:ext cx="1239956" cy="731520"/>
+          </a:xfrm>
+          <a:prstGeom prst="rect">
+            <a:avLst/>
+          </a:prstGeom>
+          <a:noFill/>
+          <a:ln/>
+        </p:spPr>
+        <p:txBody>
+          <a:bodyPr wrap="square" lIns="0" tIns="0" rIns="0" bIns="0" rtlCol="0" anchor="ctr"/>
+          <a:lstStyle/>
+          <a:p>
+            <a:pPr algn="l" indent="0" marL="0">
+              <a:buNone/>
+            </a:pPr>
+            <a:r>
+              <a:rPr lang="en-US" sz="800" dirty="0">
+                <a:solidFill>
+                  <a:srgbClr val="2E3440"/>
+                </a:solidFill>
+                <a:latin typeface="Roboto" pitchFamily="34" charset="0"/>
+                <a:ea typeface="Roboto" pitchFamily="34" charset="-122"/>
+                <a:cs typeface="Roboto" pitchFamily="34" charset="-120"/>
+              </a:rPr>
+              <a:t>Tidak ada bukti; terbukti hanya untuk kabut super-dingin</a:t>
+            </a:r>
+            <a:endParaRPr lang="en-US" sz="800" dirty="0"/>
+          </a:p>
+        </p:txBody>
+      </p:sp>
+      <p:sp>
+        <p:nvSpPr>
+          <p:cNvPr id="36" name="Text 33"/>
+          <p:cNvSpPr/>
+          <p:nvPr/>
+        </p:nvSpPr>
+        <p:spPr>
+          <a:xfrm>
+            <a:off x="2834690" y="4983480"/>
+            <a:ext cx="1383825" cy="731520"/>
+          </a:xfrm>
+          <a:prstGeom prst="rect">
+            <a:avLst/>
+          </a:prstGeom>
+          <a:noFill/>
+          <a:ln/>
+        </p:spPr>
+        <p:txBody>
+          <a:bodyPr wrap="square" lIns="0" tIns="0" rIns="0" bIns="0" rtlCol="0" anchor="ctr"/>
+          <a:lstStyle/>
+          <a:p>
+            <a:pPr algn="l" indent="0" marL="0">
+              <a:buNone/>
+            </a:pPr>
+            <a:r>
+              <a:rPr lang="en-US" sz="800" dirty="0">
+                <a:solidFill>
+                  <a:srgbClr val="2E3440"/>
+                </a:solidFill>
+                <a:latin typeface="Roboto" pitchFamily="34" charset="0"/>
+                <a:ea typeface="Roboto" pitchFamily="34" charset="-122"/>
+                <a:cs typeface="Roboto" pitchFamily="34" charset="-120"/>
+              </a:rPr>
+              <a:t>BRIN 19 Okt 2026 menyebut pembongkaran inversi masih hipotesis ilmiah.</a:t>
+            </a:r>
+            <a:endParaRPr lang="en-US" sz="800" dirty="0"/>
+          </a:p>
+        </p:txBody>
+      </p:sp>
+      <p:sp>
+        <p:nvSpPr>
+          <p:cNvPr id="37" name="Shape 34"/>
+          <p:cNvSpPr/>
+          <p:nvPr/>
+        </p:nvSpPr>
+        <p:spPr>
+          <a:xfrm>
+            <a:off x="4538556" y="1280160"/>
+            <a:ext cx="3408207" cy="4809744"/>
+          </a:xfrm>
+          <a:prstGeom prst="roundRect">
+            <a:avLst>
+              <a:gd name="adj" fmla="val 1610"/>
+            </a:avLst>
+          </a:prstGeom>
+          <a:solidFill>
+            <a:srgbClr val="FFFFFF"/>
+          </a:solidFill>
+          <a:ln w="9525">
+            <a:solidFill>
+              <a:srgbClr val="D5DAE1"/>
+            </a:solidFill>
+            <a:prstDash val="solid"/>
+          </a:ln>
+        </p:spPr>
+      </p:sp>
+      <p:sp>
+        <p:nvSpPr>
+          <p:cNvPr id="38" name="Shape 35"/>
+          <p:cNvSpPr/>
+          <p:nvPr/>
+        </p:nvSpPr>
+        <p:spPr>
+          <a:xfrm>
+            <a:off x="4538556" y="1280160"/>
+            <a:ext cx="3408207" cy="457200"/>
+          </a:xfrm>
+          <a:prstGeom prst="roundRect">
+            <a:avLst>
+              <a:gd name="adj" fmla="val 12000"/>
+            </a:avLst>
+          </a:prstGeom>
+          <a:solidFill>
+            <a:srgbClr val="E6EAF0"/>
+          </a:solidFill>
+          <a:ln/>
+        </p:spPr>
+      </p:sp>
+      <p:sp>
+        <p:nvSpPr>
+          <p:cNvPr id="39" name="Shape 36"/>
+          <p:cNvSpPr/>
+          <p:nvPr/>
+        </p:nvSpPr>
+        <p:spPr>
+          <a:xfrm>
+            <a:off x="4538556" y="1508760"/>
+            <a:ext cx="3408207" cy="228600"/>
+          </a:xfrm>
+          <a:prstGeom prst="rect">
+            <a:avLst/>
+          </a:prstGeom>
+          <a:solidFill>
+            <a:srgbClr val="E6EAF0"/>
+          </a:solidFill>
+          <a:ln/>
+        </p:spPr>
+      </p:sp>
+      <p:sp>
+        <p:nvSpPr>
+          <p:cNvPr id="40" name="Shape 37"/>
+          <p:cNvSpPr/>
+          <p:nvPr/>
+        </p:nvSpPr>
+        <p:spPr>
+          <a:xfrm>
+            <a:off x="4666572" y="1362456"/>
+            <a:ext cx="292608" cy="292608"/>
+          </a:xfrm>
+          <a:prstGeom prst="ellipse">
+            <a:avLst/>
+          </a:prstGeom>
+          <a:solidFill>
+            <a:srgbClr val="051C2C"/>
+          </a:solidFill>
+          <a:ln/>
+        </p:spPr>
+      </p:sp>
+      <p:pic>
+        <p:nvPicPr>
+          <p:cNvPr id="41" name="Image 1" descr="/Users/priyankaalfatehan28/.claude/skills/ppt-konsultan/mesin/cache-ikon/scales-regular-FFFFFF.png">    </p:cNvPr>
+          <p:cNvPicPr>
+            <a:picLocks noChangeAspect="1"/>
+          </p:cNvPicPr>
+          <p:nvPr/>
+        </p:nvPicPr>
+        <p:blipFill>
+          <a:blip r:embed="rId2"/>
+          <a:stretch>
+            <a:fillRect/>
+          </a:stretch>
+        </p:blipFill>
+        <p:spPr>
+          <a:xfrm>
+            <a:off x="4730580" y="1426464"/>
+            <a:ext cx="164592" cy="164592"/>
+          </a:xfrm>
+          <a:prstGeom prst="rect">
+            <a:avLst/>
+          </a:prstGeom>
+        </p:spPr>
+      </p:pic>
+      <p:sp>
+        <p:nvSpPr>
+          <p:cNvPr id="42" name="Text 38"/>
+          <p:cNvSpPr/>
+          <p:nvPr/>
+        </p:nvSpPr>
+        <p:spPr>
+          <a:xfrm>
+            <a:off x="5050620" y="1280160"/>
+            <a:ext cx="2758983" cy="457200"/>
+          </a:xfrm>
+          <a:prstGeom prst="rect">
+            <a:avLst/>
+          </a:prstGeom>
+          <a:noFill/>
+          <a:ln/>
+        </p:spPr>
+        <p:txBody>
+          <a:bodyPr wrap="square" lIns="0" tIns="0" rIns="0" bIns="0" rtlCol="0" anchor="ctr"/>
+          <a:lstStyle/>
+          <a:p>
+            <a:pPr indent="0" marL="0">
+              <a:buNone/>
+            </a:pPr>
+            <a:r>
+              <a:rPr lang="en-US" sz="1000" b="1" dirty="0">
+                <a:solidFill>
+                  <a:srgbClr val="1A1A1A"/>
+                </a:solidFill>
+                <a:latin typeface="Roboto" pitchFamily="34" charset="0"/>
+                <a:ea typeface="Roboto" pitchFamily="34" charset="-122"/>
+                <a:cs typeface="Roboto" pitchFamily="34" charset="-120"/>
+              </a:rPr>
+              <a:t>Klaim keberhasilan dan buktinya</a:t>
+            </a:r>
+            <a:endParaRPr lang="en-US" sz="1000" dirty="0"/>
+          </a:p>
+        </p:txBody>
+      </p:sp>
+      <p:sp>
+        <p:nvSpPr>
+          <p:cNvPr id="43" name="Text 39"/>
+          <p:cNvSpPr/>
+          <p:nvPr/>
+        </p:nvSpPr>
+        <p:spPr>
+          <a:xfrm>
+            <a:off x="4666572" y="1828800"/>
+            <a:ext cx="1269049" cy="182880"/>
+          </a:xfrm>
+          <a:prstGeom prst="rect">
+            <a:avLst/>
+          </a:prstGeom>
+          <a:noFill/>
+          <a:ln/>
+        </p:spPr>
+        <p:txBody>
+          <a:bodyPr wrap="square" lIns="0" tIns="0" rIns="0" bIns="0" rtlCol="0" anchor="ctr"/>
+          <a:lstStyle/>
+          <a:p>
+            <a:pPr algn="ctr" indent="0" marL="0">
+              <a:buNone/>
+            </a:pPr>
+            <a:r>
+              <a:rPr lang="en-US" sz="800" b="1" spc="150" kern="0" dirty="0">
+                <a:solidFill>
+                  <a:srgbClr val="6B7280"/>
+                </a:solidFill>
+                <a:latin typeface="Roboto" pitchFamily="34" charset="0"/>
+                <a:ea typeface="Roboto" pitchFamily="34" charset="-122"/>
+                <a:cs typeface="Roboto" pitchFamily="34" charset="-120"/>
+              </a:rPr>
+              <a:t>KLAIM</a:t>
+            </a:r>
+            <a:endParaRPr lang="en-US" sz="800" dirty="0"/>
+          </a:p>
+        </p:txBody>
+      </p:sp>
+      <p:sp>
+        <p:nvSpPr>
+          <p:cNvPr id="44" name="Text 40"/>
+          <p:cNvSpPr/>
+          <p:nvPr/>
+        </p:nvSpPr>
+        <p:spPr>
+          <a:xfrm>
+            <a:off x="5990485" y="1828800"/>
+            <a:ext cx="953832" cy="182880"/>
+          </a:xfrm>
+          <a:prstGeom prst="rect">
+            <a:avLst/>
+          </a:prstGeom>
+          <a:noFill/>
+          <a:ln/>
+        </p:spPr>
+        <p:txBody>
+          <a:bodyPr wrap="square" lIns="0" tIns="0" rIns="0" bIns="0" rtlCol="0" anchor="ctr"/>
+          <a:lstStyle/>
+          <a:p>
+            <a:pPr algn="ctr" indent="0" marL="0">
+              <a:buNone/>
+            </a:pPr>
+            <a:r>
+              <a:rPr lang="en-US" sz="800" b="1" spc="150" kern="0" dirty="0">
+                <a:solidFill>
+                  <a:srgbClr val="6B7280"/>
+                </a:solidFill>
+                <a:latin typeface="Roboto" pitchFamily="34" charset="0"/>
+                <a:ea typeface="Roboto" pitchFamily="34" charset="-122"/>
+                <a:cs typeface="Roboto" pitchFamily="34" charset="-120"/>
+              </a:rPr>
+              <a:t>CARA HITUNG</a:t>
+            </a:r>
+            <a:endParaRPr lang="en-US" sz="800" dirty="0"/>
+          </a:p>
+        </p:txBody>
+      </p:sp>
+      <p:sp>
+        <p:nvSpPr>
+          <p:cNvPr id="45" name="Text 41"/>
+          <p:cNvSpPr/>
+          <p:nvPr/>
+        </p:nvSpPr>
+        <p:spPr>
+          <a:xfrm>
+            <a:off x="6999181" y="1828800"/>
+            <a:ext cx="764701" cy="182880"/>
+          </a:xfrm>
+          <a:prstGeom prst="rect">
+            <a:avLst/>
+          </a:prstGeom>
+          <a:noFill/>
+          <a:ln/>
+        </p:spPr>
+        <p:txBody>
+          <a:bodyPr wrap="square" lIns="0" tIns="0" rIns="0" bIns="0" rtlCol="0" anchor="ctr"/>
+          <a:lstStyle/>
+          <a:p>
+            <a:pPr algn="ctr" indent="0" marL="0">
+              <a:buNone/>
+            </a:pPr>
+            <a:r>
+              <a:rPr lang="en-US" sz="800" b="1" spc="150" kern="0" dirty="0">
+                <a:solidFill>
+                  <a:srgbClr val="6B7280"/>
+                </a:solidFill>
+                <a:latin typeface="Roboto" pitchFamily="34" charset="0"/>
+                <a:ea typeface="Roboto" pitchFamily="34" charset="-122"/>
+                <a:cs typeface="Roboto" pitchFamily="34" charset="-120"/>
+              </a:rPr>
+              <a:t>STATUS</a:t>
+            </a:r>
+            <a:endParaRPr lang="en-US" sz="800" dirty="0"/>
+          </a:p>
+        </p:txBody>
+      </p:sp>
+      <p:sp>
+        <p:nvSpPr>
+          <p:cNvPr id="46" name="Shape 42"/>
+          <p:cNvSpPr/>
+          <p:nvPr/>
+        </p:nvSpPr>
+        <p:spPr>
+          <a:xfrm>
+            <a:off x="4666572" y="2057400"/>
+            <a:ext cx="3152175" cy="0"/>
+          </a:xfrm>
+          <a:prstGeom prst="line">
+            <a:avLst/>
+          </a:prstGeom>
+          <a:noFill/>
+          <a:ln w="9525">
+            <a:solidFill>
+              <a:srgbClr val="1A1A1A"/>
+            </a:solidFill>
+            <a:prstDash val="solid"/>
+          </a:ln>
+        </p:spPr>
+      </p:sp>
+      <p:sp>
+        <p:nvSpPr>
+          <p:cNvPr id="47" name="Text 43"/>
+          <p:cNvSpPr/>
+          <p:nvPr/>
+        </p:nvSpPr>
+        <p:spPr>
+          <a:xfrm>
+            <a:off x="4666572" y="2057400"/>
+            <a:ext cx="1269049" cy="731520"/>
+          </a:xfrm>
+          <a:prstGeom prst="rect">
+            <a:avLst/>
+          </a:prstGeom>
+          <a:noFill/>
+          <a:ln/>
+        </p:spPr>
+        <p:txBody>
+          <a:bodyPr wrap="square" lIns="0" tIns="0" rIns="0" bIns="0" rtlCol="0" anchor="ctr"/>
+          <a:lstStyle/>
+          <a:p>
+            <a:pPr algn="l" indent="0" marL="0">
+              <a:buNone/>
+            </a:pPr>
+            <a:r>
+              <a:rPr lang="en-US" sz="800" b="1" dirty="0">
+                <a:solidFill>
+                  <a:srgbClr val="1A1A1A"/>
+                </a:solidFill>
+                <a:latin typeface="Roboto" pitchFamily="34" charset="0"/>
+                <a:ea typeface="Roboto" pitchFamily="34" charset="-122"/>
+                <a:cs typeface="Roboto" pitchFamily="34" charset="-120"/>
+              </a:rPr>
+              <a:t>BMKG Jul 2025: keberhasilan penyemaian 85 sampai 100%</a:t>
+            </a:r>
+            <a:endParaRPr lang="en-US" sz="800" dirty="0"/>
+          </a:p>
+        </p:txBody>
+      </p:sp>
+      <p:sp>
+        <p:nvSpPr>
+          <p:cNvPr id="48" name="Text 44"/>
+          <p:cNvSpPr/>
+          <p:nvPr/>
+        </p:nvSpPr>
+        <p:spPr>
+          <a:xfrm>
+            <a:off x="5990485" y="2057400"/>
+            <a:ext cx="953832" cy="731520"/>
+          </a:xfrm>
+          <a:prstGeom prst="rect">
+            <a:avLst/>
+          </a:prstGeom>
+          <a:noFill/>
+          <a:ln/>
+        </p:spPr>
+        <p:txBody>
+          <a:bodyPr wrap="square" lIns="0" tIns="0" rIns="0" bIns="0" rtlCol="0" anchor="ctr"/>
+          <a:lstStyle/>
+          <a:p>
+            <a:pPr algn="l" indent="0" marL="0">
+              <a:buNone/>
+            </a:pPr>
+            <a:r>
+              <a:rPr lang="en-US" sz="800" dirty="0">
+                <a:solidFill>
+                  <a:srgbClr val="2E3440"/>
+                </a:solidFill>
+                <a:latin typeface="Roboto" pitchFamily="34" charset="0"/>
+                <a:ea typeface="Roboto" pitchFamily="34" charset="-122"/>
+                <a:cs typeface="Roboto" pitchFamily="34" charset="-120"/>
+              </a:rPr>
+              <a:t>Keberhasilan tidak didefinisikan</a:t>
+            </a:r>
+            <a:endParaRPr lang="en-US" sz="800" dirty="0"/>
+          </a:p>
+        </p:txBody>
+      </p:sp>
+      <p:sp>
+        <p:nvSpPr>
+          <p:cNvPr id="49" name="Text 45"/>
+          <p:cNvSpPr/>
+          <p:nvPr/>
+        </p:nvSpPr>
+        <p:spPr>
+          <a:xfrm>
+            <a:off x="6999181" y="2057400"/>
+            <a:ext cx="764701" cy="731520"/>
+          </a:xfrm>
+          <a:prstGeom prst="rect">
+            <a:avLst/>
+          </a:prstGeom>
+          <a:noFill/>
+          <a:ln/>
+        </p:spPr>
+        <p:txBody>
+          <a:bodyPr wrap="square" lIns="0" tIns="0" rIns="0" bIns="0" rtlCol="0" anchor="ctr"/>
+          <a:lstStyle/>
+          <a:p>
+            <a:pPr algn="l" indent="0" marL="0">
+              <a:buNone/>
+            </a:pPr>
+            <a:r>
+              <a:rPr lang="en-US" sz="800" dirty="0">
+                <a:solidFill>
+                  <a:srgbClr val="2E3440"/>
+                </a:solidFill>
+                <a:latin typeface="Roboto" pitchFamily="34" charset="0"/>
+                <a:ea typeface="Roboto" pitchFamily="34" charset="-122"/>
+                <a:cs typeface="Roboto" pitchFamily="34" charset="-120"/>
+              </a:rPr>
+              <a:t>Klaim, tidak dapat diverifikasi</a:t>
+            </a:r>
+            <a:endParaRPr lang="en-US" sz="800" dirty="0"/>
+          </a:p>
+        </p:txBody>
+      </p:sp>
+      <p:sp>
+        <p:nvSpPr>
+          <p:cNvPr id="50" name="Shape 46"/>
+          <p:cNvSpPr/>
+          <p:nvPr/>
+        </p:nvSpPr>
+        <p:spPr>
+          <a:xfrm>
+            <a:off x="4666572" y="2788920"/>
+            <a:ext cx="3152175" cy="0"/>
+          </a:xfrm>
+          <a:prstGeom prst="line">
+            <a:avLst/>
+          </a:prstGeom>
+          <a:noFill/>
+          <a:ln w="6350">
+            <a:solidFill>
+              <a:srgbClr val="E3E6EA"/>
+            </a:solidFill>
+            <a:prstDash val="solid"/>
+          </a:ln>
+        </p:spPr>
+      </p:sp>
+      <p:sp>
+        <p:nvSpPr>
+          <p:cNvPr id="51" name="Text 47"/>
+          <p:cNvSpPr/>
+          <p:nvPr/>
+        </p:nvSpPr>
+        <p:spPr>
+          <a:xfrm>
+            <a:off x="4666572" y="2788920"/>
+            <a:ext cx="1269049" cy="731520"/>
+          </a:xfrm>
+          <a:prstGeom prst="rect">
+            <a:avLst/>
+          </a:prstGeom>
+          <a:noFill/>
+          <a:ln/>
+        </p:spPr>
+        <p:txBody>
+          <a:bodyPr wrap="square" lIns="0" tIns="0" rIns="0" bIns="0" rtlCol="0" anchor="ctr"/>
+          <a:lstStyle/>
+          <a:p>
+            <a:pPr algn="l" indent="0" marL="0">
+              <a:buNone/>
+            </a:pPr>
+            <a:r>
+              <a:rPr lang="en-US" sz="800" b="1" dirty="0">
+                <a:solidFill>
+                  <a:srgbClr val="1A1A1A"/>
+                </a:solidFill>
+                <a:latin typeface="Roboto" pitchFamily="34" charset="0"/>
+                <a:ea typeface="Roboto" pitchFamily="34" charset="-122"/>
+                <a:cs typeface="Roboto" pitchFamily="34" charset="-120"/>
+              </a:rPr>
+              <a:t>BMKG: karhutla turun rata-rata 23% (2016 sampai 2019)</a:t>
+            </a:r>
+            <a:endParaRPr lang="en-US" sz="800" dirty="0"/>
+          </a:p>
+        </p:txBody>
+      </p:sp>
+      <p:sp>
+        <p:nvSpPr>
+          <p:cNvPr id="52" name="Text 48"/>
+          <p:cNvSpPr/>
+          <p:nvPr/>
+        </p:nvSpPr>
+        <p:spPr>
+          <a:xfrm>
+            <a:off x="5990485" y="2788920"/>
+            <a:ext cx="953832" cy="731520"/>
+          </a:xfrm>
+          <a:prstGeom prst="rect">
+            <a:avLst/>
+          </a:prstGeom>
+          <a:noFill/>
+          <a:ln/>
+        </p:spPr>
+        <p:txBody>
+          <a:bodyPr wrap="square" lIns="0" tIns="0" rIns="0" bIns="0" rtlCol="0" anchor="ctr"/>
+          <a:lstStyle/>
+          <a:p>
+            <a:pPr algn="l" indent="0" marL="0">
+              <a:buNone/>
+            </a:pPr>
+            <a:r>
+              <a:rPr lang="en-US" sz="800" dirty="0">
+                <a:solidFill>
+                  <a:srgbClr val="2E3440"/>
+                </a:solidFill>
+                <a:latin typeface="Roboto" pitchFamily="34" charset="0"/>
+                <a:ea typeface="Roboto" pitchFamily="34" charset="-122"/>
+                <a:cs typeface="Roboto" pitchFamily="34" charset="-120"/>
+              </a:rPr>
+              <a:t>Baseline, metrik, dan data tidak disebut</a:t>
+            </a:r>
+            <a:endParaRPr lang="en-US" sz="800" dirty="0"/>
+          </a:p>
+        </p:txBody>
+      </p:sp>
+      <p:sp>
+        <p:nvSpPr>
+          <p:cNvPr id="53" name="Text 49"/>
+          <p:cNvSpPr/>
+          <p:nvPr/>
+        </p:nvSpPr>
+        <p:spPr>
+          <a:xfrm>
+            <a:off x="6999181" y="2788920"/>
+            <a:ext cx="764701" cy="731520"/>
+          </a:xfrm>
+          <a:prstGeom prst="rect">
+            <a:avLst/>
+          </a:prstGeom>
+          <a:noFill/>
+          <a:ln/>
+        </p:spPr>
+        <p:txBody>
+          <a:bodyPr wrap="square" lIns="0" tIns="0" rIns="0" bIns="0" rtlCol="0" anchor="ctr"/>
+          <a:lstStyle/>
+          <a:p>
+            <a:pPr algn="l" indent="0" marL="0">
+              <a:buNone/>
+            </a:pPr>
+            <a:r>
+              <a:rPr lang="en-US" sz="800" dirty="0">
+                <a:solidFill>
+                  <a:srgbClr val="2E3440"/>
+                </a:solidFill>
+                <a:latin typeface="Roboto" pitchFamily="34" charset="0"/>
+                <a:ea typeface="Roboto" pitchFamily="34" charset="-122"/>
+                <a:cs typeface="Roboto" pitchFamily="34" charset="-120"/>
+              </a:rPr>
+              <a:t>Klaim, tidak dapat diverifikasi</a:t>
+            </a:r>
+            <a:endParaRPr lang="en-US" sz="800" dirty="0"/>
+          </a:p>
+        </p:txBody>
+      </p:sp>
+      <p:sp>
+        <p:nvSpPr>
+          <p:cNvPr id="54" name="Shape 50"/>
+          <p:cNvSpPr/>
+          <p:nvPr/>
+        </p:nvSpPr>
+        <p:spPr>
+          <a:xfrm>
+            <a:off x="4666572" y="3520440"/>
+            <a:ext cx="3152175" cy="0"/>
+          </a:xfrm>
+          <a:prstGeom prst="line">
+            <a:avLst/>
+          </a:prstGeom>
+          <a:noFill/>
+          <a:ln w="6350">
+            <a:solidFill>
+              <a:srgbClr val="E3E6EA"/>
+            </a:solidFill>
+            <a:prstDash val="solid"/>
+          </a:ln>
+        </p:spPr>
+      </p:sp>
+      <p:sp>
+        <p:nvSpPr>
+          <p:cNvPr id="55" name="Text 51"/>
+          <p:cNvSpPr/>
+          <p:nvPr/>
+        </p:nvSpPr>
+        <p:spPr>
+          <a:xfrm>
+            <a:off x="4666572" y="3520440"/>
+            <a:ext cx="1269049" cy="731520"/>
+          </a:xfrm>
+          <a:prstGeom prst="rect">
+            <a:avLst/>
+          </a:prstGeom>
+          <a:noFill/>
+          <a:ln/>
+        </p:spPr>
+        <p:txBody>
+          <a:bodyPr wrap="square" lIns="0" tIns="0" rIns="0" bIns="0" rtlCol="0" anchor="ctr"/>
+          <a:lstStyle/>
+          <a:p>
+            <a:pPr algn="l" indent="0" marL="0">
+              <a:buNone/>
+            </a:pPr>
+            <a:r>
+              <a:rPr lang="en-US" sz="800" b="1" dirty="0">
+                <a:solidFill>
+                  <a:srgbClr val="1A1A1A"/>
+                </a:solidFill>
+                <a:latin typeface="Roboto" pitchFamily="34" charset="0"/>
+                <a:ea typeface="Roboto" pitchFamily="34" charset="-122"/>
+                <a:cs typeface="Roboto" pitchFamily="34" charset="-120"/>
+              </a:rPr>
+              <a:t>BNPB 21 Okt 2026: hujan di 3 dari 4 provinsi, jarak pandang 1.000 m ke 7.000 m</a:t>
+            </a:r>
+            <a:endParaRPr lang="en-US" sz="800" dirty="0"/>
+          </a:p>
+        </p:txBody>
+      </p:sp>
+      <p:sp>
+        <p:nvSpPr>
+          <p:cNvPr id="56" name="Text 52"/>
+          <p:cNvSpPr/>
+          <p:nvPr/>
+        </p:nvSpPr>
+        <p:spPr>
+          <a:xfrm>
+            <a:off x="5990485" y="3520440"/>
+            <a:ext cx="953832" cy="731520"/>
+          </a:xfrm>
+          <a:prstGeom prst="rect">
+            <a:avLst/>
+          </a:prstGeom>
+          <a:noFill/>
+          <a:ln/>
+        </p:spPr>
+        <p:txBody>
+          <a:bodyPr wrap="square" lIns="0" tIns="0" rIns="0" bIns="0" rtlCol="0" anchor="ctr"/>
+          <a:lstStyle/>
+          <a:p>
+            <a:pPr algn="l" indent="0" marL="0">
+              <a:buNone/>
+            </a:pPr>
+            <a:r>
+              <a:rPr lang="en-US" sz="800" dirty="0">
+                <a:solidFill>
+                  <a:srgbClr val="2E3440"/>
+                </a:solidFill>
+                <a:latin typeface="Roboto" pitchFamily="34" charset="0"/>
+                <a:ea typeface="Roboto" pitchFamily="34" charset="-122"/>
+                <a:cs typeface="Roboto" pitchFamily="34" charset="-120"/>
+              </a:rPr>
+              <a:t>Hitungan kabupaten, sortie, jarak pandang; tanpa kontrol</a:t>
+            </a:r>
+            <a:endParaRPr lang="en-US" sz="800" dirty="0"/>
+          </a:p>
+        </p:txBody>
+      </p:sp>
+      <p:sp>
+        <p:nvSpPr>
+          <p:cNvPr id="57" name="Text 53"/>
+          <p:cNvSpPr/>
+          <p:nvPr/>
+        </p:nvSpPr>
+        <p:spPr>
+          <a:xfrm>
+            <a:off x="6999181" y="3520440"/>
+            <a:ext cx="764701" cy="731520"/>
+          </a:xfrm>
+          <a:prstGeom prst="rect">
+            <a:avLst/>
+          </a:prstGeom>
+          <a:noFill/>
+          <a:ln/>
+        </p:spPr>
+        <p:txBody>
+          <a:bodyPr wrap="square" lIns="0" tIns="0" rIns="0" bIns="0" rtlCol="0" anchor="ctr"/>
+          <a:lstStyle/>
+          <a:p>
+            <a:pPr algn="l" indent="0" marL="0">
+              <a:buNone/>
+            </a:pPr>
+            <a:r>
+              <a:rPr lang="en-US" sz="800" dirty="0">
+                <a:solidFill>
+                  <a:srgbClr val="2E3440"/>
+                </a:solidFill>
+                <a:latin typeface="Roboto" pitchFamily="34" charset="0"/>
+                <a:ea typeface="Roboto" pitchFamily="34" charset="-122"/>
+                <a:cs typeface="Roboto" pitchFamily="34" charset="-120"/>
+              </a:rPr>
+              <a:t>Ukuran proses, efek tidak terukur</a:t>
+            </a:r>
+            <a:endParaRPr lang="en-US" sz="800" dirty="0"/>
+          </a:p>
+        </p:txBody>
+      </p:sp>
+      <p:sp>
+        <p:nvSpPr>
+          <p:cNvPr id="58" name="Shape 54"/>
+          <p:cNvSpPr/>
+          <p:nvPr/>
+        </p:nvSpPr>
+        <p:spPr>
+          <a:xfrm>
+            <a:off x="4666572" y="4251960"/>
+            <a:ext cx="3152175" cy="0"/>
+          </a:xfrm>
+          <a:prstGeom prst="line">
+            <a:avLst/>
+          </a:prstGeom>
+          <a:noFill/>
+          <a:ln w="6350">
+            <a:solidFill>
+              <a:srgbClr val="E3E6EA"/>
+            </a:solidFill>
+            <a:prstDash val="solid"/>
+          </a:ln>
+        </p:spPr>
+      </p:sp>
+      <p:sp>
+        <p:nvSpPr>
+          <p:cNvPr id="59" name="Text 55"/>
+          <p:cNvSpPr/>
+          <p:nvPr/>
+        </p:nvSpPr>
+        <p:spPr>
+          <a:xfrm>
+            <a:off x="4666572" y="4251960"/>
+            <a:ext cx="1269049" cy="731520"/>
+          </a:xfrm>
+          <a:prstGeom prst="rect">
+            <a:avLst/>
+          </a:prstGeom>
+          <a:noFill/>
+          <a:ln/>
+        </p:spPr>
+        <p:txBody>
+          <a:bodyPr wrap="square" lIns="0" tIns="0" rIns="0" bIns="0" rtlCol="0" anchor="ctr"/>
+          <a:lstStyle/>
+          <a:p>
+            <a:pPr algn="l" indent="0" marL="0">
+              <a:buNone/>
+            </a:pPr>
+            <a:r>
+              <a:rPr lang="en-US" sz="800" b="1" dirty="0">
+                <a:solidFill>
+                  <a:srgbClr val="1A1A1A"/>
+                </a:solidFill>
+                <a:latin typeface="Roboto" pitchFamily="34" charset="0"/>
+                <a:ea typeface="Roboto" pitchFamily="34" charset="-122"/>
+                <a:cs typeface="Roboto" pitchFamily="34" charset="-120"/>
+              </a:rPr>
+              <a:t>BMKG Sep 2026: Kalbar 27 sortie berhasil memicu hujan</a:t>
+            </a:r>
+            <a:endParaRPr lang="en-US" sz="800" dirty="0"/>
+          </a:p>
+        </p:txBody>
+      </p:sp>
+      <p:sp>
+        <p:nvSpPr>
+          <p:cNvPr id="60" name="Text 56"/>
+          <p:cNvSpPr/>
+          <p:nvPr/>
+        </p:nvSpPr>
+        <p:spPr>
+          <a:xfrm>
+            <a:off x="5990485" y="4251960"/>
+            <a:ext cx="953832" cy="731520"/>
+          </a:xfrm>
+          <a:prstGeom prst="rect">
+            <a:avLst/>
+          </a:prstGeom>
+          <a:noFill/>
+          <a:ln/>
+        </p:spPr>
+        <p:txBody>
+          <a:bodyPr wrap="square" lIns="0" tIns="0" rIns="0" bIns="0" rtlCol="0" anchor="ctr"/>
+          <a:lstStyle/>
+          <a:p>
+            <a:pPr algn="l" indent="0" marL="0">
+              <a:buNone/>
+            </a:pPr>
+            <a:r>
+              <a:rPr lang="en-US" sz="800" dirty="0">
+                <a:solidFill>
+                  <a:srgbClr val="2E3440"/>
+                </a:solidFill>
+                <a:latin typeface="Roboto" pitchFamily="34" charset="0"/>
+                <a:ea typeface="Roboto" pitchFamily="34" charset="-122"/>
+                <a:cs typeface="Roboto" pitchFamily="34" charset="-120"/>
+              </a:rPr>
+              <a:t>Tanpa metrik</a:t>
+            </a:r>
+            <a:endParaRPr lang="en-US" sz="800" dirty="0"/>
+          </a:p>
+        </p:txBody>
+      </p:sp>
+      <p:sp>
+        <p:nvSpPr>
+          <p:cNvPr id="61" name="Text 57"/>
+          <p:cNvSpPr/>
+          <p:nvPr/>
+        </p:nvSpPr>
+        <p:spPr>
+          <a:xfrm>
+            <a:off x="6999181" y="4251960"/>
+            <a:ext cx="764701" cy="731520"/>
+          </a:xfrm>
+          <a:prstGeom prst="rect">
+            <a:avLst/>
+          </a:prstGeom>
+          <a:noFill/>
+          <a:ln/>
+        </p:spPr>
+        <p:txBody>
+          <a:bodyPr wrap="square" lIns="0" tIns="0" rIns="0" bIns="0" rtlCol="0" anchor="ctr"/>
+          <a:lstStyle/>
+          <a:p>
+            <a:pPr algn="l" indent="0" marL="0">
+              <a:buNone/>
+            </a:pPr>
+            <a:r>
+              <a:rPr lang="en-US" sz="800" dirty="0">
+                <a:solidFill>
+                  <a:srgbClr val="2E3440"/>
+                </a:solidFill>
+                <a:latin typeface="Roboto" pitchFamily="34" charset="0"/>
+                <a:ea typeface="Roboto" pitchFamily="34" charset="-122"/>
+                <a:cs typeface="Roboto" pitchFamily="34" charset="-120"/>
+              </a:rPr>
+              <a:t>Klaim</a:t>
+            </a:r>
+            <a:endParaRPr lang="en-US" sz="800" dirty="0"/>
+          </a:p>
+        </p:txBody>
+      </p:sp>
+      <p:sp>
+        <p:nvSpPr>
+          <p:cNvPr id="62" name="Shape 58"/>
+          <p:cNvSpPr/>
+          <p:nvPr/>
+        </p:nvSpPr>
+        <p:spPr>
+          <a:xfrm>
+            <a:off x="4666572" y="4983480"/>
+            <a:ext cx="3152175" cy="0"/>
+          </a:xfrm>
+          <a:prstGeom prst="line">
+            <a:avLst/>
+          </a:prstGeom>
+          <a:noFill/>
+          <a:ln w="6350">
+            <a:solidFill>
+              <a:srgbClr val="E3E6EA"/>
+            </a:solidFill>
+            <a:prstDash val="solid"/>
+          </a:ln>
+        </p:spPr>
+      </p:sp>
+      <p:sp>
+        <p:nvSpPr>
+          <p:cNvPr id="63" name="Text 59"/>
+          <p:cNvSpPr/>
+          <p:nvPr/>
+        </p:nvSpPr>
+        <p:spPr>
+          <a:xfrm>
+            <a:off x="4666572" y="4983480"/>
+            <a:ext cx="1269049" cy="731520"/>
+          </a:xfrm>
+          <a:prstGeom prst="rect">
+            <a:avLst/>
+          </a:prstGeom>
+          <a:noFill/>
+          <a:ln/>
+        </p:spPr>
+        <p:txBody>
+          <a:bodyPr wrap="square" lIns="0" tIns="0" rIns="0" bIns="0" rtlCol="0" anchor="ctr"/>
+          <a:lstStyle/>
+          <a:p>
+            <a:pPr algn="l" indent="0" marL="0">
+              <a:buNone/>
+            </a:pPr>
+            <a:r>
+              <a:rPr lang="en-US" sz="800" b="1" dirty="0">
+                <a:solidFill>
+                  <a:srgbClr val="1A1A1A"/>
+                </a:solidFill>
+                <a:latin typeface="Roboto" pitchFamily="34" charset="0"/>
+                <a:ea typeface="Roboto" pitchFamily="34" charset="-122"/>
+                <a:cs typeface="Roboto" pitchFamily="34" charset="-120"/>
+              </a:rPr>
+              <a:t>Pola umum</a:t>
+            </a:r>
+            <a:endParaRPr lang="en-US" sz="800" dirty="0"/>
+          </a:p>
+        </p:txBody>
+      </p:sp>
+      <p:sp>
+        <p:nvSpPr>
+          <p:cNvPr id="64" name="Text 60"/>
+          <p:cNvSpPr/>
+          <p:nvPr/>
+        </p:nvSpPr>
+        <p:spPr>
+          <a:xfrm>
+            <a:off x="5990485" y="4983480"/>
+            <a:ext cx="953832" cy="731520"/>
+          </a:xfrm>
+          <a:prstGeom prst="rect">
+            <a:avLst/>
+          </a:prstGeom>
+          <a:noFill/>
+          <a:ln/>
+        </p:spPr>
+        <p:txBody>
+          <a:bodyPr wrap="square" lIns="0" tIns="0" rIns="0" bIns="0" rtlCol="0" anchor="ctr"/>
+          <a:lstStyle/>
+          <a:p>
+            <a:pPr algn="l" indent="0" marL="0">
+              <a:buNone/>
+            </a:pPr>
+            <a:r>
+              <a:rPr lang="en-US" sz="800" dirty="0">
+                <a:solidFill>
+                  <a:srgbClr val="2E3440"/>
+                </a:solidFill>
+                <a:latin typeface="Roboto" pitchFamily="34" charset="0"/>
+                <a:ea typeface="Roboto" pitchFamily="34" charset="-122"/>
+                <a:cs typeface="Roboto" pitchFamily="34" charset="-120"/>
+              </a:rPr>
+              <a:t>Hari atau kabupaten hujan tanpa pembanding</a:t>
+            </a:r>
+            <a:endParaRPr lang="en-US" sz="800" dirty="0"/>
+          </a:p>
+        </p:txBody>
+      </p:sp>
+      <p:sp>
+        <p:nvSpPr>
+          <p:cNvPr id="65" name="Text 61"/>
+          <p:cNvSpPr/>
+          <p:nvPr/>
+        </p:nvSpPr>
+        <p:spPr>
+          <a:xfrm>
+            <a:off x="6999181" y="4983480"/>
+            <a:ext cx="764701" cy="731520"/>
+          </a:xfrm>
+          <a:prstGeom prst="rect">
+            <a:avLst/>
+          </a:prstGeom>
+          <a:noFill/>
+          <a:ln/>
+        </p:spPr>
+        <p:txBody>
+          <a:bodyPr wrap="square" lIns="0" tIns="0" rIns="0" bIns="0" rtlCol="0" anchor="ctr"/>
+          <a:lstStyle/>
+          <a:p>
+            <a:pPr algn="l" indent="0" marL="0">
+              <a:buNone/>
+            </a:pPr>
+            <a:r>
+              <a:rPr lang="en-US" sz="800" dirty="0">
+                <a:solidFill>
+                  <a:srgbClr val="2E3440"/>
+                </a:solidFill>
+                <a:latin typeface="Roboto" pitchFamily="34" charset="0"/>
+                <a:ea typeface="Roboto" pitchFamily="34" charset="-122"/>
+                <a:cs typeface="Roboto" pitchFamily="34" charset="-120"/>
+              </a:rPr>
+              <a:t>Hujan di musim peralihan tampak sukses tanpa semai</a:t>
+            </a:r>
+            <a:endParaRPr lang="en-US" sz="800" dirty="0"/>
+          </a:p>
+        </p:txBody>
+      </p:sp>
+      <p:sp>
+        <p:nvSpPr>
+          <p:cNvPr id="66" name="Shape 62"/>
+          <p:cNvSpPr/>
+          <p:nvPr/>
+        </p:nvSpPr>
+        <p:spPr>
+          <a:xfrm>
+            <a:off x="8083922" y="1280160"/>
+            <a:ext cx="3556390" cy="4809744"/>
+          </a:xfrm>
+          <a:prstGeom prst="roundRect">
+            <a:avLst>
+              <a:gd name="adj" fmla="val 1543"/>
+            </a:avLst>
+          </a:prstGeom>
+          <a:solidFill>
+            <a:srgbClr val="FFFFFF"/>
+          </a:solidFill>
+          <a:ln w="9525">
+            <a:solidFill>
+              <a:srgbClr val="D5DAE1"/>
+            </a:solidFill>
+            <a:prstDash val="solid"/>
+          </a:ln>
+        </p:spPr>
+      </p:sp>
+      <p:sp>
+        <p:nvSpPr>
+          <p:cNvPr id="67" name="Shape 63"/>
+          <p:cNvSpPr/>
+          <p:nvPr/>
+        </p:nvSpPr>
+        <p:spPr>
+          <a:xfrm>
+            <a:off x="8083922" y="1280160"/>
+            <a:ext cx="3556390" cy="457200"/>
+          </a:xfrm>
+          <a:prstGeom prst="roundRect">
+            <a:avLst>
+              <a:gd name="adj" fmla="val 12000"/>
+            </a:avLst>
+          </a:prstGeom>
+          <a:solidFill>
+            <a:srgbClr val="E6EAF0"/>
+          </a:solidFill>
+          <a:ln/>
+        </p:spPr>
+      </p:sp>
+      <p:sp>
+        <p:nvSpPr>
+          <p:cNvPr id="68" name="Shape 64"/>
+          <p:cNvSpPr/>
+          <p:nvPr/>
+        </p:nvSpPr>
+        <p:spPr>
+          <a:xfrm>
+            <a:off x="8083922" y="1508760"/>
+            <a:ext cx="3556390" cy="228600"/>
+          </a:xfrm>
+          <a:prstGeom prst="rect">
+            <a:avLst/>
+          </a:prstGeom>
+          <a:solidFill>
+            <a:srgbClr val="E6EAF0"/>
+          </a:solidFill>
+          <a:ln/>
+        </p:spPr>
+      </p:sp>
+      <p:sp>
+        <p:nvSpPr>
+          <p:cNvPr id="69" name="Shape 65"/>
+          <p:cNvSpPr/>
+          <p:nvPr/>
+        </p:nvSpPr>
+        <p:spPr>
+          <a:xfrm>
+            <a:off x="8211938" y="1362456"/>
+            <a:ext cx="292608" cy="292608"/>
+          </a:xfrm>
+          <a:prstGeom prst="ellipse">
+            <a:avLst/>
+          </a:prstGeom>
+          <a:solidFill>
+            <a:srgbClr val="051C2C"/>
+          </a:solidFill>
+          <a:ln/>
+        </p:spPr>
+      </p:sp>
+      <p:pic>
+        <p:nvPicPr>
+          <p:cNvPr id="70" name="Image 2" descr="/Users/priyankaalfatehan28/.claude/skills/ppt-konsultan/mesin/cache-ikon/list-checks-regular-FFFFFF.png">    </p:cNvPr>
+          <p:cNvPicPr>
+            <a:picLocks noChangeAspect="1"/>
+          </p:cNvPicPr>
+          <p:nvPr/>
+        </p:nvPicPr>
+        <p:blipFill>
+          <a:blip r:embed="rId3"/>
+          <a:stretch>
+            <a:fillRect/>
+          </a:stretch>
+        </p:blipFill>
+        <p:spPr>
+          <a:xfrm>
+            <a:off x="8275946" y="1426464"/>
+            <a:ext cx="164592" cy="164592"/>
+          </a:xfrm>
+          <a:prstGeom prst="rect">
+            <a:avLst/>
+          </a:prstGeom>
+        </p:spPr>
+      </p:pic>
+      <p:sp>
+        <p:nvSpPr>
+          <p:cNvPr id="71" name="Text 66"/>
+          <p:cNvSpPr/>
+          <p:nvPr/>
+        </p:nvSpPr>
+        <p:spPr>
+          <a:xfrm>
+            <a:off x="8595986" y="1280160"/>
+            <a:ext cx="2907166" cy="457200"/>
+          </a:xfrm>
+          <a:prstGeom prst="rect">
+            <a:avLst/>
+          </a:prstGeom>
+          <a:noFill/>
+          <a:ln/>
+        </p:spPr>
+        <p:txBody>
+          <a:bodyPr wrap="square" lIns="0" tIns="0" rIns="0" bIns="0" rtlCol="0" anchor="ctr"/>
+          <a:lstStyle/>
+          <a:p>
+            <a:pPr indent="0" marL="0">
+              <a:buNone/>
+            </a:pPr>
+            <a:r>
+              <a:rPr lang="en-US" sz="1000" b="1" dirty="0">
+                <a:solidFill>
+                  <a:srgbClr val="1A1A1A"/>
+                </a:solidFill>
+                <a:latin typeface="Roboto" pitchFamily="34" charset="0"/>
+                <a:ea typeface="Roboto" pitchFamily="34" charset="-122"/>
+                <a:cs typeface="Roboto" pitchFamily="34" charset="-120"/>
+              </a:rPr>
+              <a:t>Kesimpulan untuk OMC Oktober 2026</a:t>
+            </a:r>
+            <a:endParaRPr lang="en-US" sz="1000" dirty="0"/>
+          </a:p>
+        </p:txBody>
+      </p:sp>
+      <p:sp>
+        <p:nvSpPr>
+          <p:cNvPr id="72" name="Text 67"/>
+          <p:cNvSpPr/>
+          <p:nvPr/>
+        </p:nvSpPr>
+        <p:spPr>
+          <a:xfrm>
+            <a:off x="8211938" y="1828800"/>
+            <a:ext cx="1188720" cy="365760"/>
+          </a:xfrm>
+          <a:prstGeom prst="rect">
+            <a:avLst/>
+          </a:prstGeom>
+          <a:noFill/>
+          <a:ln/>
+        </p:spPr>
+        <p:txBody>
+          <a:bodyPr wrap="square" lIns="0" tIns="0" rIns="0" bIns="0" rtlCol="0" anchor="ctr"/>
+          <a:lstStyle/>
+          <a:p>
+            <a:pPr indent="0" marL="0">
+              <a:buNone/>
+            </a:pPr>
+            <a:r>
+              <a:rPr lang="en-US" sz="1400" b="1" dirty="0">
+                <a:solidFill>
+                  <a:srgbClr val="D9600B"/>
+                </a:solidFill>
+                <a:latin typeface="Roboto" pitchFamily="34" charset="0"/>
+                <a:ea typeface="Roboto" pitchFamily="34" charset="-122"/>
+                <a:cs typeface="Roboto" pitchFamily="34" charset="-120"/>
+              </a:rPr>
+              <a:t>7 dari 7</a:t>
+            </a:r>
+            <a:endParaRPr lang="en-US" sz="1400" dirty="0"/>
+          </a:p>
+        </p:txBody>
+      </p:sp>
+      <p:sp>
+        <p:nvSpPr>
+          <p:cNvPr id="73" name="Text 68"/>
+          <p:cNvSpPr/>
+          <p:nvPr/>
+        </p:nvSpPr>
+        <p:spPr>
+          <a:xfrm>
+            <a:off x="9446378" y="1828800"/>
+            <a:ext cx="2065918" cy="365760"/>
+          </a:xfrm>
+          <a:prstGeom prst="rect">
+            <a:avLst/>
+          </a:prstGeom>
+          <a:noFill/>
+          <a:ln/>
+        </p:spPr>
+        <p:txBody>
+          <a:bodyPr wrap="square" lIns="0" tIns="0" rIns="0" bIns="0" rtlCol="0" anchor="ctr"/>
+          <a:lstStyle/>
+          <a:p>
+            <a:pPr indent="0" marL="0">
+              <a:buNone/>
+            </a:pPr>
+            <a:r>
+              <a:rPr lang="en-US" sz="800" dirty="0">
+                <a:solidFill>
+                  <a:srgbClr val="2E3440"/>
+                </a:solidFill>
+                <a:latin typeface="Roboto" pitchFamily="34" charset="0"/>
+                <a:ea typeface="Roboto" pitchFamily="34" charset="-122"/>
+                <a:cs typeface="Roboto" pitchFamily="34" charset="-120"/>
+              </a:rPr>
+              <a:t>hari operasi Kalbar dengan hujan di Ketapang</a:t>
+            </a:r>
+            <a:endParaRPr lang="en-US" sz="800" dirty="0"/>
+          </a:p>
+        </p:txBody>
+      </p:sp>
+      <p:sp>
+        <p:nvSpPr>
+          <p:cNvPr id="74" name="Shape 69"/>
+          <p:cNvSpPr/>
+          <p:nvPr/>
+        </p:nvSpPr>
+        <p:spPr>
+          <a:xfrm>
+            <a:off x="8211938" y="2221992"/>
+            <a:ext cx="3300358" cy="0"/>
+          </a:xfrm>
+          <a:prstGeom prst="line">
+            <a:avLst/>
+          </a:prstGeom>
+          <a:noFill/>
+          <a:ln w="6350">
+            <a:solidFill>
+              <a:srgbClr val="E3E6EA"/>
+            </a:solidFill>
+            <a:prstDash val="solid"/>
+          </a:ln>
+        </p:spPr>
+      </p:sp>
+      <p:sp>
+        <p:nvSpPr>
+          <p:cNvPr id="75" name="Text 70"/>
+          <p:cNvSpPr/>
+          <p:nvPr/>
+        </p:nvSpPr>
+        <p:spPr>
+          <a:xfrm>
+            <a:off x="8211938" y="2249424"/>
+            <a:ext cx="1188720" cy="365760"/>
+          </a:xfrm>
+          <a:prstGeom prst="rect">
+            <a:avLst/>
+          </a:prstGeom>
+          <a:noFill/>
+          <a:ln/>
+        </p:spPr>
+        <p:txBody>
+          <a:bodyPr wrap="square" lIns="0" tIns="0" rIns="0" bIns="0" rtlCol="0" anchor="ctr"/>
+          <a:lstStyle/>
+          <a:p>
+            <a:pPr indent="0" marL="0">
+              <a:buNone/>
+            </a:pPr>
+            <a:r>
+              <a:rPr lang="en-US" sz="1400" b="1" dirty="0">
+                <a:solidFill>
+                  <a:srgbClr val="051C2C"/>
+                </a:solidFill>
+                <a:latin typeface="Roboto" pitchFamily="34" charset="0"/>
+                <a:ea typeface="Roboto" pitchFamily="34" charset="-122"/>
+                <a:cs typeface="Roboto" pitchFamily="34" charset="-120"/>
+              </a:rPr>
+              <a:t>6 dari 11</a:t>
+            </a:r>
+            <a:endParaRPr lang="en-US" sz="1400" dirty="0"/>
+          </a:p>
+        </p:txBody>
+      </p:sp>
+      <p:sp>
+        <p:nvSpPr>
+          <p:cNvPr id="76" name="Text 71"/>
+          <p:cNvSpPr/>
+          <p:nvPr/>
+        </p:nvSpPr>
+        <p:spPr>
+          <a:xfrm>
+            <a:off x="9446378" y="2249424"/>
+            <a:ext cx="2065918" cy="365760"/>
+          </a:xfrm>
+          <a:prstGeom prst="rect">
+            <a:avLst/>
+          </a:prstGeom>
+          <a:noFill/>
+          <a:ln/>
+        </p:spPr>
+        <p:txBody>
+          <a:bodyPr wrap="square" lIns="0" tIns="0" rIns="0" bIns="0" rtlCol="0" anchor="ctr"/>
+          <a:lstStyle/>
+          <a:p>
+            <a:pPr indent="0" marL="0">
+              <a:buNone/>
+            </a:pPr>
+            <a:r>
+              <a:rPr lang="en-US" sz="800" dirty="0">
+                <a:solidFill>
+                  <a:srgbClr val="2E3440"/>
+                </a:solidFill>
+                <a:latin typeface="Roboto" pitchFamily="34" charset="0"/>
+                <a:ea typeface="Roboto" pitchFamily="34" charset="-122"/>
+                <a:cs typeface="Roboto" pitchFamily="34" charset="-120"/>
+              </a:rPr>
+              <a:t>hari operasi Kalteng dengan hujan di Kotawaringin Barat</a:t>
+            </a:r>
+            <a:endParaRPr lang="en-US" sz="800" dirty="0"/>
+          </a:p>
+        </p:txBody>
+      </p:sp>
+      <p:sp>
+        <p:nvSpPr>
+          <p:cNvPr id="77" name="Shape 72"/>
+          <p:cNvSpPr/>
+          <p:nvPr/>
+        </p:nvSpPr>
+        <p:spPr>
+          <a:xfrm>
+            <a:off x="8211938" y="2642616"/>
+            <a:ext cx="3300358" cy="0"/>
+          </a:xfrm>
+          <a:prstGeom prst="line">
+            <a:avLst/>
+          </a:prstGeom>
+          <a:noFill/>
+          <a:ln w="6350">
+            <a:solidFill>
+              <a:srgbClr val="E3E6EA"/>
+            </a:solidFill>
+            <a:prstDash val="solid"/>
+          </a:ln>
+        </p:spPr>
+      </p:sp>
+      <p:sp>
+        <p:nvSpPr>
+          <p:cNvPr id="78" name="Text 73"/>
+          <p:cNvSpPr/>
+          <p:nvPr/>
+        </p:nvSpPr>
+        <p:spPr>
+          <a:xfrm>
+            <a:off x="8211938" y="2670048"/>
+            <a:ext cx="1188720" cy="365760"/>
+          </a:xfrm>
+          <a:prstGeom prst="rect">
+            <a:avLst/>
+          </a:prstGeom>
+          <a:noFill/>
+          <a:ln/>
+        </p:spPr>
+        <p:txBody>
+          <a:bodyPr wrap="square" lIns="0" tIns="0" rIns="0" bIns="0" rtlCol="0" anchor="ctr"/>
+          <a:lstStyle/>
+          <a:p>
+            <a:pPr indent="0" marL="0">
+              <a:buNone/>
+            </a:pPr>
+            <a:r>
+              <a:rPr lang="en-US" sz="1400" b="1" dirty="0">
+                <a:solidFill>
+                  <a:srgbClr val="051C2C"/>
+                </a:solidFill>
+                <a:latin typeface="Roboto" pitchFamily="34" charset="0"/>
+                <a:ea typeface="Roboto" pitchFamily="34" charset="-122"/>
+                <a:cs typeface="Roboto" pitchFamily="34" charset="-120"/>
+              </a:rPr>
+              <a:t>sekitar 700</a:t>
+            </a:r>
+            <a:endParaRPr lang="en-US" sz="1400" dirty="0"/>
+          </a:p>
+        </p:txBody>
+      </p:sp>
+      <p:sp>
+        <p:nvSpPr>
+          <p:cNvPr id="79" name="Text 74"/>
+          <p:cNvSpPr/>
+          <p:nvPr/>
+        </p:nvSpPr>
+        <p:spPr>
+          <a:xfrm>
+            <a:off x="9446378" y="2670048"/>
+            <a:ext cx="2065918" cy="365760"/>
+          </a:xfrm>
+          <a:prstGeom prst="rect">
+            <a:avLst/>
+          </a:prstGeom>
+          <a:noFill/>
+          <a:ln/>
+        </p:spPr>
+        <p:txBody>
+          <a:bodyPr wrap="square" lIns="0" tIns="0" rIns="0" bIns="0" rtlCol="0" anchor="ctr"/>
+          <a:lstStyle/>
+          <a:p>
+            <a:pPr indent="0" marL="0">
+              <a:buNone/>
+            </a:pPr>
+            <a:r>
+              <a:rPr lang="en-US" sz="800" dirty="0">
+                <a:solidFill>
+                  <a:srgbClr val="2E3440"/>
+                </a:solidFill>
+                <a:latin typeface="Roboto" pitchFamily="34" charset="0"/>
+                <a:ea typeface="Roboto" pitchFamily="34" charset="-122"/>
+                <a:cs typeface="Roboto" pitchFamily="34" charset="-120"/>
+              </a:rPr>
+              <a:t>kasus per kelompok untuk mendeteksi efek 15% (perkiraan kasar)</a:t>
+            </a:r>
+            <a:endParaRPr lang="en-US" sz="800" dirty="0"/>
+          </a:p>
+        </p:txBody>
+      </p:sp>
+      <p:sp>
+        <p:nvSpPr>
+          <p:cNvPr id="80" name="Shape 75"/>
+          <p:cNvSpPr/>
+          <p:nvPr/>
+        </p:nvSpPr>
+        <p:spPr>
+          <a:xfrm>
+            <a:off x="8211938" y="3063240"/>
+            <a:ext cx="3300358" cy="0"/>
+          </a:xfrm>
+          <a:prstGeom prst="line">
+            <a:avLst/>
+          </a:prstGeom>
+          <a:noFill/>
+          <a:ln w="6350">
+            <a:solidFill>
+              <a:srgbClr val="E3E6EA"/>
+            </a:solidFill>
+            <a:prstDash val="solid"/>
+          </a:ln>
+        </p:spPr>
+      </p:sp>
+      <p:sp>
+        <p:nvSpPr>
+          <p:cNvPr id="81" name="Text 76"/>
+          <p:cNvSpPr/>
+          <p:nvPr/>
+        </p:nvSpPr>
+        <p:spPr>
+          <a:xfrm>
+            <a:off x="8211938" y="3090672"/>
+            <a:ext cx="1188720" cy="365760"/>
+          </a:xfrm>
+          <a:prstGeom prst="rect">
+            <a:avLst/>
+          </a:prstGeom>
+          <a:noFill/>
+          <a:ln/>
+        </p:spPr>
+        <p:txBody>
+          <a:bodyPr wrap="square" lIns="0" tIns="0" rIns="0" bIns="0" rtlCol="0" anchor="ctr"/>
+          <a:lstStyle/>
+          <a:p>
+            <a:pPr indent="0" marL="0">
+              <a:buNone/>
+            </a:pPr>
+            <a:r>
+              <a:rPr lang="en-US" sz="1400" b="1" dirty="0">
+                <a:solidFill>
+                  <a:srgbClr val="051C2C"/>
+                </a:solidFill>
+                <a:latin typeface="Roboto" pitchFamily="34" charset="0"/>
+                <a:ea typeface="Roboto" pitchFamily="34" charset="-122"/>
+                <a:cs typeface="Roboto" pitchFamily="34" charset="-120"/>
+              </a:rPr>
+              <a:t>11 hari</a:t>
+            </a:r>
+            <a:endParaRPr lang="en-US" sz="1400" dirty="0"/>
+          </a:p>
+        </p:txBody>
+      </p:sp>
+      <p:sp>
+        <p:nvSpPr>
+          <p:cNvPr id="82" name="Text 77"/>
+          <p:cNvSpPr/>
+          <p:nvPr/>
+        </p:nvSpPr>
+        <p:spPr>
+          <a:xfrm>
+            <a:off x="9446378" y="3090672"/>
+            <a:ext cx="2065918" cy="365760"/>
+          </a:xfrm>
+          <a:prstGeom prst="rect">
+            <a:avLst/>
+          </a:prstGeom>
+          <a:noFill/>
+          <a:ln/>
+        </p:spPr>
+        <p:txBody>
+          <a:bodyPr wrap="square" lIns="0" tIns="0" rIns="0" bIns="0" rtlCol="0" anchor="ctr"/>
+          <a:lstStyle/>
+          <a:p>
+            <a:pPr indent="0" marL="0">
+              <a:buNone/>
+            </a:pPr>
+            <a:r>
+              <a:rPr lang="en-US" sz="800" dirty="0">
+                <a:solidFill>
+                  <a:srgbClr val="2E3440"/>
+                </a:solidFill>
+                <a:latin typeface="Roboto" pitchFamily="34" charset="0"/>
+                <a:ea typeface="Roboto" pitchFamily="34" charset="-122"/>
+                <a:cs typeface="Roboto" pitchFamily="34" charset="-120"/>
+              </a:rPr>
+              <a:t>operasi Kalteng dan Sumsel, jauh di bawah kebutuhan sampel</a:t>
+            </a:r>
+            <a:endParaRPr lang="en-US" sz="800" dirty="0"/>
+          </a:p>
+        </p:txBody>
+      </p:sp>
+      <p:sp>
+        <p:nvSpPr>
+          <p:cNvPr id="83" name="Text 78"/>
+          <p:cNvSpPr/>
+          <p:nvPr/>
+        </p:nvSpPr>
+        <p:spPr>
+          <a:xfrm>
+            <a:off x="8211938" y="3639312"/>
+            <a:ext cx="3300358" cy="1577340"/>
+          </a:xfrm>
+          <a:prstGeom prst="rect">
+            <a:avLst/>
+          </a:prstGeom>
+          <a:noFill/>
+          <a:ln/>
+        </p:spPr>
+        <p:txBody>
+          <a:bodyPr wrap="square" lIns="0" tIns="0" rIns="0" bIns="0" rtlCol="0" anchor="t"/>
+          <a:lstStyle/>
+          <a:p>
+            <a:pPr marL="114300" indent="-114300">
+              <a:buSzPct val="100000"/>
+              <a:buChar char="•"/>
+            </a:pPr>
+            <a:r>
+              <a:rPr lang="en-US" sz="800" b="1" dirty="0">
+                <a:solidFill>
+                  <a:srgbClr val="1A1A1A"/>
+                </a:solidFill>
+                <a:latin typeface="Roboto" pitchFamily="34" charset="0"/>
+                <a:ea typeface="Roboto" pitchFamily="34" charset="-122"/>
+                <a:cs typeface="Roboto" pitchFamily="34" charset="-120"/>
+              </a:rPr>
+              <a:t>Yang bisa dikatakan:</a:t>
+            </a:r>
+            <a:r>
+              <a:rPr lang="en-US" sz="800" dirty="0">
+                <a:solidFill>
+                  <a:srgbClr val="2E3440"/>
+                </a:solidFill>
+                <a:latin typeface="Roboto" pitchFamily="34" charset="0"/>
+                <a:ea typeface="Roboto" pitchFamily="34" charset="-122"/>
+                <a:cs typeface="Roboto" pitchFamily="34" charset="-120"/>
+              </a:rPr>
+              <a:t> hujan dilaporkan di wilayah sasaran pada sejumlah hari operasi (slide 2).</a:t>
+            </a:r>
+            <a:endParaRPr lang="en-US" sz="800" dirty="0"/>
+          </a:p>
+          <a:p>
+            <a:pPr marL="114300" indent="-114300">
+              <a:spcBef>
+                <a:spcPts val="400"/>
+              </a:spcBef>
+              <a:buSzPct val="100000"/>
+              <a:buChar char="•"/>
+            </a:pPr>
+            <a:r>
+              <a:rPr lang="en-US" sz="800" b="1" dirty="0">
+                <a:solidFill>
+                  <a:srgbClr val="1A1A1A"/>
+                </a:solidFill>
+                <a:latin typeface="Roboto" pitchFamily="34" charset="0"/>
+                <a:ea typeface="Roboto" pitchFamily="34" charset="-122"/>
+                <a:cs typeface="Roboto" pitchFamily="34" charset="-120"/>
+              </a:rPr>
+              <a:t>Yang tidak bisa dikatakan:</a:t>
+            </a:r>
+            <a:r>
+              <a:rPr lang="en-US" sz="800" dirty="0">
+                <a:solidFill>
+                  <a:srgbClr val="2E3440"/>
+                </a:solidFill>
+                <a:latin typeface="Roboto" pitchFamily="34" charset="0"/>
+                <a:ea typeface="Roboto" pitchFamily="34" charset="-122"/>
+                <a:cs typeface="Roboto" pitchFamily="34" charset="-120"/>
+              </a:rPr>
+              <a:t> persentase hujan akibat OMC. Wilayah yang tidak disemai sebagai pembanding belum ada, dan Oktober adalah musim peralihan.</a:t>
+            </a:r>
+            <a:endParaRPr lang="en-US" sz="800" dirty="0"/>
+          </a:p>
+          <a:p>
+            <a:pPr marL="114300" indent="-114300">
+              <a:spcBef>
+                <a:spcPts val="400"/>
+              </a:spcBef>
+              <a:buSzPct val="100000"/>
+              <a:buChar char="•"/>
+            </a:pPr>
+            <a:r>
+              <a:rPr lang="en-US" sz="800" b="1" dirty="0">
+                <a:solidFill>
+                  <a:srgbClr val="1A1A1A"/>
+                </a:solidFill>
+                <a:latin typeface="Roboto" pitchFamily="34" charset="0"/>
+                <a:ea typeface="Roboto" pitchFamily="34" charset="-122"/>
+                <a:cs typeface="Roboto" pitchFamily="34" charset="-120"/>
+              </a:rPr>
+              <a:t>Kebutuhan data:</a:t>
+            </a:r>
+            <a:r>
+              <a:rPr lang="en-US" sz="800" dirty="0">
+                <a:solidFill>
+                  <a:srgbClr val="2E3440"/>
+                </a:solidFill>
+                <a:latin typeface="Roboto" pitchFamily="34" charset="0"/>
+                <a:ea typeface="Roboto" pitchFamily="34" charset="-122"/>
+                <a:cs typeface="Roboto" pitchFamily="34" charset="-120"/>
+              </a:rPr>
+              <a:t> mendeteksi efek sekitar 15% butuh ratusan kab-hari per kelompok; 11 hari operasi tidak cukup.</a:t>
+            </a:r>
+            <a:endParaRPr lang="en-US" sz="800" dirty="0"/>
+          </a:p>
+          <a:p>
+            <a:pPr marL="114300" indent="-114300">
+              <a:spcBef>
+                <a:spcPts val="400"/>
+              </a:spcBef>
+              <a:buSzPct val="100000"/>
+              <a:buChar char="•"/>
+            </a:pPr>
+            <a:r>
+              <a:rPr lang="en-US" sz="800" b="1" dirty="0">
+                <a:solidFill>
+                  <a:srgbClr val="1A1A1A"/>
+                </a:solidFill>
+                <a:latin typeface="Roboto" pitchFamily="34" charset="0"/>
+                <a:ea typeface="Roboto" pitchFamily="34" charset="-122"/>
+                <a:cs typeface="Roboto" pitchFamily="34" charset="-120"/>
+              </a:rPr>
+              <a:t>Ke depan:</a:t>
+            </a:r>
+            <a:r>
+              <a:rPr lang="en-US" sz="800" dirty="0">
+                <a:solidFill>
+                  <a:srgbClr val="2E3440"/>
+                </a:solidFill>
+                <a:latin typeface="Roboto" pitchFamily="34" charset="0"/>
+                <a:ea typeface="Roboto" pitchFamily="34" charset="-122"/>
+                <a:cs typeface="Roboto" pitchFamily="34" charset="-120"/>
+              </a:rPr>
+              <a:t> catat jam dan koordinat lintasan semai tiap sortie, tetapkan wilayah kontrol tiap hari, pulihkan arsip PM2,5 BMKG.</a:t>
+            </a:r>
+            <a:endParaRPr lang="en-US" sz="800" dirty="0"/>
+          </a:p>
+          <a:p>
+            <a:pPr marL="114300" indent="-114300">
+              <a:spcBef>
+                <a:spcPts val="400"/>
+              </a:spcBef>
+              <a:buSzPct val="100000"/>
+              <a:buChar char="•"/>
+            </a:pPr>
+            <a:r>
+              <a:rPr lang="en-US" sz="800" b="1" dirty="0">
+                <a:solidFill>
+                  <a:srgbClr val="1A1A1A"/>
+                </a:solidFill>
+                <a:latin typeface="Roboto" pitchFamily="34" charset="0"/>
+                <a:ea typeface="Roboto" pitchFamily="34" charset="-122"/>
+                <a:cs typeface="Roboto" pitchFamily="34" charset="-120"/>
+              </a:rPr>
+              <a:t>Sedang dihitung:</a:t>
+            </a:r>
+            <a:r>
+              <a:rPr lang="en-US" sz="800" dirty="0">
+                <a:solidFill>
+                  <a:srgbClr val="2E3440"/>
+                </a:solidFill>
+                <a:latin typeface="Roboto" pitchFamily="34" charset="0"/>
+                <a:ea typeface="Roboto" pitchFamily="34" charset="-122"/>
+                <a:cs typeface="Roboto" pitchFamily="34" charset="-120"/>
+              </a:rPr>
+              <a:t> uji wilayah sasaran lawan kontrol dengan data satelit; hasilnya ditambahkan.</a:t>
+            </a:r>
+            <a:endParaRPr lang="en-US" sz="800" dirty="0"/>
+          </a:p>
+        </p:txBody>
+      </p:sp>
+      <p:sp>
+        <p:nvSpPr>
+          <p:cNvPr id="25" name="Slide Number Placeholder 0"/>
+          <p:cNvSpPr>
+            <a:spLocks noGrp="1"/>
+          </p:cNvSpPr>
+          <p:nvPr>
+            <p:ph type="sldNum" sz="quarter" idx="4294967295"/>
+          </p:nvPr>
+        </p:nvSpPr>
+        <p:spPr>
+          <a:xfrm>
+            <a:off x="11091672" y="6510020"/>
+            <a:ext cx="548640" cy="219456"/>
+          </a:xfrm>
+          <a:prstGeom prst="rect">
+            <a:avLst/>
+          </a:prstGeom>
+          <a:extLst>
+            <a:ext uri="{C572A759-6A51-4108-AA02-DFA0A04FC94B}">
+              <ma14:wrappingTextBoxFlag xmlns:ma14="http://schemas.microsoft.com/office/mac/drawingml/2011/main" val="0"/>
+            </a:ext>
+          </a:extLst>
+        </p:spPr>
+        <p:txBody>
+          <a:bodyPr/>
+          <a:lstStyle>
+            <a:lvl1pPr>
+              <a:defRPr sz="800">
+                <a:solidFill>
+                  <a:srgbClr val="1A1A1A"/>
+                </a:solidFill>
+                <a:latin typeface="Roboto"/>
+                <a:ea typeface="Roboto"/>
+                <a:cs typeface="Roboto"/>
+              </a:defRPr>
+            </a:lvl1pPr>
+          </a:lstStyle>
+          <a:p>
+            <a:pPr algn="r"/>
+            <a:fld id="{F7021451-1387-4CA6-816F-3879F97B5CBC}" type="slidenum">
+              <a:rPr b="1" lang="en-US"/>
+              <a:t>3</a:t>
             </a:fld>
             <a:endParaRPr lang="en-US"/>
           </a:p>

</xml_diff>

<commit_message>
OMC: slide 3 memuat hasil uji satelit
Co-Authored-By: Claude Opus 5.5 <noreply@anthropic.com>
</commit_message>
<xml_diff>
--- a/data/laporan-bnpb/omc/OMC_Karhutla_16-27Okt2026.pptx
+++ b/data/laporan-bnpb/omc/OMC_Karhutla_16-27Okt2026.pptx
@@ -11554,7 +11554,7 @@
                 <a:ea typeface="Roboto" pitchFamily="34" charset="-122"/>
                 <a:cs typeface="Roboto" pitchFamily="34" charset="-120"/>
               </a:rPr>
-              <a:t>Bukti dunia: penyemaian garam paling banyak menambah sekitar </a:t>
+              <a:t>Bukti dunia paling banyak sekitar </a:t>
             </a:r>
             <a:r>
               <a:rPr lang="en-US" sz="2200" b="1" dirty="0">
@@ -11576,7 +11576,7 @@
                 <a:ea typeface="Roboto" pitchFamily="34" charset="-122"/>
                 <a:cs typeface="Roboto" pitchFamily="34" charset="-120"/>
               </a:rPr>
-              <a:t> hujan, dry ice untuk asap belum terbukti</a:t>
+              <a:t> tambahan hujan; uji satelit OMC Oktober 2026 belum mendeteksi efek</a:t>
             </a:r>
             <a:endParaRPr lang="en-US" sz="2200" dirty="0"/>
           </a:p>
@@ -11757,7 +11757,7 @@
                 <a:ea typeface="Roboto" pitchFamily="34" charset="-122"/>
                 <a:cs typeface="Roboto" pitchFamily="34" charset="-120"/>
               </a:rPr>
-              <a:t>WMO 2025; IITM 2023 (CAIPEEX-IV); Israel-4; Silverman 2003; BRIN 19 Okt 2026; BMKG Jul 2025; BNPB 21 Okt 2026</a:t>
+              <a:t>WMO 2025; IITM 2023 (CAIPEEX-IV); Israel-4; Silverman 2003; BRIN 19 Okt 2026; BMKG Jul 2025; BNPB 21 Okt 2026; CHIRPS prelim (CHC UCSB); prakiraan ECMWF IFS</a:t>
             </a:r>
             <a:endParaRPr lang="en-US" sz="900" dirty="0"/>
           </a:p>
@@ -13523,7 +13523,7 @@
         <p:spPr>
           <a:xfrm>
             <a:off x="8334248" y="1828800"/>
-            <a:ext cx="1188720" cy="749808"/>
+            <a:ext cx="1371600" cy="749808"/>
           </a:xfrm>
           <a:prstGeom prst="rect">
             <a:avLst/>
@@ -13539,7 +13539,7 @@
               <a:buNone/>
             </a:pPr>
             <a:r>
-              <a:rPr lang="en-US" sz="1600" b="1" dirty="0">
+              <a:rPr lang="en-US" sz="1400" b="1" dirty="0">
                 <a:solidFill>
                   <a:srgbClr val="D9600B"/>
                 </a:solidFill>
@@ -13547,9 +13547,9 @@
                 <a:ea typeface="Roboto" pitchFamily="34" charset="-122"/>
                 <a:cs typeface="Roboto" pitchFamily="34" charset="-120"/>
               </a:rPr>
-              <a:t>7 dari 7</a:t>
-            </a:r>
-            <a:endParaRPr lang="en-US" sz="1600" dirty="0"/>
+              <a:t>83 dari 113</a:t>
+            </a:r>
+            <a:endParaRPr lang="en-US" sz="1400" dirty="0"/>
           </a:p>
         </p:txBody>
       </p:sp>
@@ -13561,8 +13561,8 @@
         </p:nvSpPr>
         <p:spPr>
           <a:xfrm>
-            <a:off x="9568688" y="1828800"/>
-            <a:ext cx="1943608" cy="749808"/>
+            <a:off x="9751568" y="1828800"/>
+            <a:ext cx="1760728" cy="749808"/>
           </a:xfrm>
           <a:prstGeom prst="rect">
             <a:avLst/>
@@ -13586,7 +13586,7 @@
                 <a:ea typeface="Roboto" pitchFamily="34" charset="-122"/>
                 <a:cs typeface="Roboto" pitchFamily="34" charset="-120"/>
               </a:rPr>
-              <a:t>hari OMC di Kalbar, Ketapang dilaporkan hujan</a:t>
+              <a:t>klaim hujan di laporan harian terkonfirmasi data satelit (CHIRPS)</a:t>
             </a:r>
             <a:endParaRPr lang="en-US" sz="900" dirty="0"/>
           </a:p>
@@ -13624,7 +13624,7 @@
         <p:spPr>
           <a:xfrm>
             <a:off x="8334248" y="2633472"/>
-            <a:ext cx="1188720" cy="749808"/>
+            <a:ext cx="1371600" cy="749808"/>
           </a:xfrm>
           <a:prstGeom prst="rect">
             <a:avLst/>
@@ -13640,7 +13640,7 @@
               <a:buNone/>
             </a:pPr>
             <a:r>
-              <a:rPr lang="en-US" sz="1600" b="1" dirty="0">
+              <a:rPr lang="en-US" sz="1400" b="1" dirty="0">
                 <a:solidFill>
                   <a:srgbClr val="051C2C"/>
                 </a:solidFill>
@@ -13648,9 +13648,9 @@
                 <a:ea typeface="Roboto" pitchFamily="34" charset="-122"/>
                 <a:cs typeface="Roboto" pitchFamily="34" charset="-120"/>
               </a:rPr>
-              <a:t>6 dari 11</a:t>
-            </a:r>
-            <a:endParaRPr lang="en-US" sz="1600" dirty="0"/>
+              <a:t>Tidak terdeteksi</a:t>
+            </a:r>
+            <a:endParaRPr lang="en-US" sz="1400" dirty="0"/>
           </a:p>
         </p:txBody>
       </p:sp>
@@ -13662,8 +13662,8 @@
         </p:nvSpPr>
         <p:spPr>
           <a:xfrm>
-            <a:off x="9568688" y="2633472"/>
-            <a:ext cx="1943608" cy="749808"/>
+            <a:off x="9751568" y="2633472"/>
+            <a:ext cx="1760728" cy="749808"/>
           </a:xfrm>
           <a:prstGeom prst="rect">
             <a:avLst/>
@@ -13687,7 +13687,7 @@
                 <a:ea typeface="Roboto" pitchFamily="34" charset="-122"/>
                 <a:cs typeface="Roboto" pitchFamily="34" charset="-120"/>
               </a:rPr>
-              <a:t>hari OMC di Kalteng, Kotawaringin Barat dilaporkan hujan</a:t>
+              <a:t>efek OMC ke hujan: kabupaten disemai lawan tidak disemai -24%, rentang -121% sampai +73%</a:t>
             </a:r>
             <a:endParaRPr lang="en-US" sz="900" dirty="0"/>
           </a:p>
@@ -13725,7 +13725,7 @@
         <p:spPr>
           <a:xfrm>
             <a:off x="8334248" y="3438144"/>
-            <a:ext cx="1188720" cy="749808"/>
+            <a:ext cx="1371600" cy="749808"/>
           </a:xfrm>
           <a:prstGeom prst="rect">
             <a:avLst/>
@@ -13741,7 +13741,7 @@
               <a:buNone/>
             </a:pPr>
             <a:r>
-              <a:rPr lang="en-US" sz="1600" b="1" dirty="0">
+              <a:rPr lang="en-US" sz="1400" b="1" dirty="0">
                 <a:solidFill>
                   <a:srgbClr val="051C2C"/>
                 </a:solidFill>
@@ -13749,9 +13749,9 @@
                 <a:ea typeface="Roboto" pitchFamily="34" charset="-122"/>
                 <a:cs typeface="Roboto" pitchFamily="34" charset="-120"/>
               </a:rPr>
-              <a:t>sekitar 700</a:t>
-            </a:r>
-            <a:endParaRPr lang="en-US" sz="1600" dirty="0"/>
+              <a:t>2 kali lipat</a:t>
+            </a:r>
+            <a:endParaRPr lang="en-US" sz="1400" dirty="0"/>
           </a:p>
         </p:txBody>
       </p:sp>
@@ -13763,8 +13763,8 @@
         </p:nvSpPr>
         <p:spPr>
           <a:xfrm>
-            <a:off x="9568688" y="3438144"/>
-            <a:ext cx="1943608" cy="749808"/>
+            <a:off x="9751568" y="3438144"/>
+            <a:ext cx="1760728" cy="749808"/>
           </a:xfrm>
           <a:prstGeom prst="rect">
             <a:avLst/>
@@ -13788,7 +13788,7 @@
                 <a:ea typeface="Roboto" pitchFamily="34" charset="-122"/>
                 <a:cs typeface="Roboto" pitchFamily="34" charset="-120"/>
               </a:rPr>
-              <a:t>kasus per kelompok untuk mendeteksi efek 15% (perkiraan kasar hitungan sendiri)</a:t>
+              <a:t>efek terkecil yang bisa terlihat dengan data 9 hari operasi</a:t>
             </a:r>
             <a:endParaRPr lang="en-US" sz="900" dirty="0"/>
           </a:p>
@@ -13803,7 +13803,7 @@
         <p:spPr>
           <a:xfrm>
             <a:off x="8334248" y="4370832"/>
-            <a:ext cx="3178048" cy="1210437"/>
+            <a:ext cx="3178048" cy="1353312"/>
           </a:xfrm>
           <a:prstGeom prst="rect">
             <a:avLst/>
@@ -13828,7 +13828,7 @@
                 <a:ea typeface="Roboto" pitchFamily="34" charset="-122"/>
                 <a:cs typeface="Roboto" pitchFamily="34" charset="-120"/>
               </a:rPr>
-              <a:t>Bisa dikatakan:</a:t>
+              <a:t>Dry ice disemai di hari dan tempat yang memang kering:</a:t>
             </a:r>
             <a:r>
               <a:rPr lang="en-US" sz="900" dirty="0">
@@ -13839,7 +13839,7 @@
                 <a:ea typeface="Roboto" pitchFamily="34" charset="-122"/>
                 <a:cs typeface="Roboto" pitchFamily="34" charset="-120"/>
               </a:rPr>
-              <a:t> hujan dilaporkan di wilayah sasaran pada sejumlah hari operasi.</a:t>
+              <a:t> prakiraan 2,2 mm lawan 8,0 mm di wilayah lain, jadi angka dry ice tidak boleh dibaca sebagai efek.</a:t>
             </a:r>
             <a:endParaRPr lang="en-US" sz="900" dirty="0"/>
           </a:p>
@@ -13860,7 +13860,7 @@
                 <a:ea typeface="Roboto" pitchFamily="34" charset="-122"/>
                 <a:cs typeface="Roboto" pitchFamily="34" charset="-120"/>
               </a:rPr>
-              <a:t>Belum bisa dikatakan:</a:t>
+              <a:t>Sumsel hampir tidak teruji:</a:t>
             </a:r>
             <a:r>
               <a:rPr lang="en-US" sz="900" dirty="0">
@@ -13871,7 +13871,7 @@
                 <a:ea typeface="Roboto" pitchFamily="34" charset="-122"/>
                 <a:cs typeface="Roboto" pitchFamily="34" charset="-120"/>
               </a:rPr>
-              <a:t> berapa persen hujan akibat OMC, karena belum ada wilayah pembanding tanpa penyemaian.</a:t>
+              <a:t> sasarannya ditulis sebagai arah, misalnya timur laut Palembang, tidak sebagai kabupaten.</a:t>
             </a:r>
             <a:endParaRPr lang="en-US" sz="900" dirty="0"/>
           </a:p>
@@ -13903,7 +13903,7 @@
                 <a:ea typeface="Roboto" pitchFamily="34" charset="-122"/>
                 <a:cs typeface="Roboto" pitchFamily="34" charset="-120"/>
               </a:rPr>
-              <a:t> catat jam dan lintasan tiap sortie, tetapkan wilayah kontrol harian, pulihkan arsip PM2,5.</a:t>
+              <a:t> catat jam dan lintasan tiap sortie, tetapkan wilayah kontrol, gunakan data satelit per jam.</a:t>
             </a:r>
             <a:endParaRPr lang="en-US" sz="900" dirty="0"/>
           </a:p>

</xml_diff>